<commit_message>
Enhance Chomado slides with more cute design and content
Co-authored-by: Copilot <223556219+Copilot@users.noreply.github.com>
</commit_message>
<xml_diff>
--- a/slides/chomado-intro-2026-05-30.pptx
+++ b/slides/chomado-intro-2026-05-30.pptx
@@ -13,6 +13,8 @@
     <p:sldId id="261" r:id="rId12"/>
     <p:sldId id="262" r:id="rId13"/>
     <p:sldId id="263" r:id="rId14"/>
+    <p:sldId id="264" r:id="rId15"/>
+    <p:sldId id="265" r:id="rId16"/>
   </p:sldIdLst>
   <p:sldSz cx="9144000" cy="6858000" type="screen4x3"/>
   <p:notesSz cx="6858000" cy="9144000"/>
@@ -3110,7 +3112,7 @@
             <a:avLst/>
           </a:prstGeom>
           <a:solidFill>
-            <a:srgbClr val="FFF2F7"/>
+            <a:srgbClr val="FFE5F0"/>
           </a:solidFill>
           <a:ln>
             <a:noFill/>
@@ -3146,14 +3148,14 @@
         </p:nvSpPr>
         <p:spPr>
           <a:xfrm>
-            <a:off x="10515600" y="182880"/>
-            <a:ext cx="1371600" cy="1371600"/>
+            <a:off x="10698480" y="91440"/>
+            <a:ext cx="1280160" cy="1280160"/>
           </a:xfrm>
           <a:prstGeom prst="ellipse">
             <a:avLst/>
           </a:prstGeom>
           <a:solidFill>
-            <a:srgbClr val="FFD6E6"/>
+            <a:srgbClr val="FFA8C4"/>
           </a:solidFill>
           <a:ln>
             <a:noFill/>
@@ -3189,14 +3191,14 @@
         </p:nvSpPr>
         <p:spPr>
           <a:xfrm>
-            <a:off x="182880" y="5669280"/>
+            <a:off x="91440" y="5486400"/>
             <a:ext cx="1097280" cy="1097280"/>
           </a:xfrm>
           <a:prstGeom prst="ellipse">
             <a:avLst/>
           </a:prstGeom>
           <a:solidFill>
-            <a:srgbClr val="CEEBFF"/>
+            <a:srgbClr val="E2F2FF"/>
           </a:solidFill>
           <a:ln>
             <a:noFill/>
@@ -3226,14 +3228,57 @@
       </p:sp>
       <p:sp>
         <p:nvSpPr>
-          <p:cNvPr id="5" name="TextBox 4"/>
+          <p:cNvPr id="5" name="Oval 4"/>
+          <p:cNvSpPr/>
+          <p:nvPr/>
+        </p:nvSpPr>
+        <p:spPr>
+          <a:xfrm>
+            <a:off x="9875520" y="5943600"/>
+            <a:ext cx="548640" cy="548640"/>
+          </a:xfrm>
+          <a:prstGeom prst="ellipse">
+            <a:avLst/>
+          </a:prstGeom>
+          <a:solidFill>
+            <a:srgbClr val="EFE8FF"/>
+          </a:solidFill>
+          <a:ln>
+            <a:noFill/>
+          </a:ln>
+        </p:spPr>
+        <p:style>
+          <a:lnRef idx="1">
+            <a:schemeClr val="accent1"/>
+          </a:lnRef>
+          <a:fillRef idx="3">
+            <a:schemeClr val="accent1"/>
+          </a:fillRef>
+          <a:effectRef idx="2">
+            <a:schemeClr val="accent1"/>
+          </a:effectRef>
+          <a:fontRef idx="minor">
+            <a:schemeClr val="lt1"/>
+          </a:fontRef>
+        </p:style>
+        <p:txBody>
+          <a:bodyPr rtlCol="0" anchor="ctr"/>
+          <a:lstStyle/>
+          <a:p>
+            <a:pPr algn="ctr"/>
+          </a:p>
+        </p:txBody>
+      </p:sp>
+      <p:sp>
+        <p:nvSpPr>
+          <p:cNvPr id="6" name="TextBox 5"/>
           <p:cNvSpPr txBox="1"/>
           <p:nvPr/>
         </p:nvSpPr>
         <p:spPr>
           <a:xfrm>
-            <a:off x="731520" y="640080"/>
-            <a:ext cx="10241280" cy="1097280"/>
+            <a:off x="640080" y="365760"/>
+            <a:ext cx="10607040" cy="822960"/>
           </a:xfrm>
           <a:prstGeom prst="rect">
             <a:avLst/>
@@ -3246,10 +3291,10 @@
           </a:bodyPr>
           <a:lstStyle/>
           <a:p>
-            <a:pPr algn="l">
-              <a:defRPr sz="4000" b="1">
+            <a:pPr>
+              <a:defRPr b="1" sz="3800">
                 <a:solidFill>
-                  <a:srgbClr val="4D4D66"/>
+                  <a:srgbClr val="584A7A"/>
                 </a:solidFill>
                 <a:latin typeface="Meiryo"/>
               </a:defRPr>
@@ -3262,55 +3307,500 @@
       </p:sp>
       <p:sp>
         <p:nvSpPr>
-          <p:cNvPr id="6" name="TextBox 5"/>
-          <p:cNvSpPr txBox="1"/>
+          <p:cNvPr id="7" name="Rounded Rectangle 6"/>
+          <p:cNvSpPr/>
           <p:nvPr/>
         </p:nvSpPr>
         <p:spPr>
           <a:xfrm>
-            <a:off x="914400" y="1920240"/>
-            <a:ext cx="9875520" cy="4114800"/>
-          </a:xfrm>
-          <a:prstGeom prst="rect">
-            <a:avLst/>
-          </a:prstGeom>
-          <a:noFill/>
-        </p:spPr>
-        <p:txBody>
-          <a:bodyPr wrap="square">
-            <a:spAutoFit/>
-          </a:bodyPr>
-          <a:lstStyle/>
-          <a:p>
-            <a:pPr>
-              <a:spcAft>
-                <a:spcPts val="1200"/>
-              </a:spcAft>
-              <a:defRPr sz="2800">
+            <a:off x="731520" y="1234440"/>
+            <a:ext cx="6035040" cy="594360"/>
+          </a:xfrm>
+          <a:prstGeom prst="roundRect">
+            <a:avLst/>
+          </a:prstGeom>
+          <a:solidFill>
+            <a:srgbClr val="FFFFFF"/>
+          </a:solidFill>
+          <a:ln>
+            <a:solidFill>
+              <a:srgbClr val="FFA8C4"/>
+            </a:solidFill>
+          </a:ln>
+        </p:spPr>
+        <p:style>
+          <a:lnRef idx="1">
+            <a:schemeClr val="accent1"/>
+          </a:lnRef>
+          <a:fillRef idx="3">
+            <a:schemeClr val="accent1"/>
+          </a:fillRef>
+          <a:effectRef idx="2">
+            <a:schemeClr val="accent1"/>
+          </a:effectRef>
+          <a:fontRef idx="minor">
+            <a:schemeClr val="lt1"/>
+          </a:fontRef>
+        </p:style>
+        <p:txBody>
+          <a:bodyPr rtlCol="0" anchor="ctr"/>
+          <a:lstStyle/>
+          <a:p>
+            <a:pPr algn="ctr">
+              <a:defRPr sz="2000" b="1">
                 <a:solidFill>
-                  <a:srgbClr val="404040"/>
+                  <a:srgbClr val="584A7A"/>
                 </a:solidFill>
                 <a:latin typeface="Meiryo"/>
               </a:defRPr>
             </a:pPr>
             <a:r>
-              <a:t>• 5/30 Special Event</a:t>
-            </a:r>
-          </a:p>
-          <a:p>
-            <a:pPr>
+              <a:t>5/30 Special Event</a:t>
+            </a:r>
+          </a:p>
+        </p:txBody>
+      </p:sp>
+      <p:sp>
+        <p:nvSpPr>
+          <p:cNvPr id="8" name="Rounded Rectangle 7"/>
+          <p:cNvSpPr/>
+          <p:nvPr/>
+        </p:nvSpPr>
+        <p:spPr>
+          <a:xfrm>
+            <a:off x="731520" y="2011680"/>
+            <a:ext cx="10058400" cy="4023360"/>
+          </a:xfrm>
+          <a:prstGeom prst="roundRect">
+            <a:avLst/>
+          </a:prstGeom>
+          <a:solidFill>
+            <a:srgbClr val="FFFFFF"/>
+          </a:solidFill>
+          <a:ln>
+            <a:solidFill>
+              <a:srgbClr val="E6E6F0"/>
+            </a:solidFill>
+          </a:ln>
+        </p:spPr>
+        <p:style>
+          <a:lnRef idx="1">
+            <a:schemeClr val="accent1"/>
+          </a:lnRef>
+          <a:fillRef idx="3">
+            <a:schemeClr val="accent1"/>
+          </a:fillRef>
+          <a:effectRef idx="2">
+            <a:schemeClr val="accent1"/>
+          </a:effectRef>
+          <a:fontRef idx="minor">
+            <a:schemeClr val="lt1"/>
+          </a:fontRef>
+        </p:style>
+        <p:txBody>
+          <a:bodyPr rtlCol="0" anchor="ctr" wrap="square"/>
+          <a:lstStyle/>
+          <a:p>
+            <a:pPr algn="l">
               <a:spcAft>
-                <a:spcPts val="1200"/>
+                <a:spcPts val="1000"/>
               </a:spcAft>
-              <a:defRPr sz="2800">
+              <a:defRPr sz="2200">
                 <a:solidFill>
-                  <a:srgbClr val="404040"/>
+                  <a:srgbClr val="464650"/>
                 </a:solidFill>
                 <a:latin typeface="Meiryo"/>
               </a:defRPr>
             </a:pPr>
             <a:r>
-              <a:t>• 技術を、もっと楽しく。もっとやさしく。</a:t>
+              <a:t>★ 技術を、もっと楽しく。もっとやさしく。</a:t>
+            </a:r>
+          </a:p>
+          <a:p>
+            <a:pPr algn="l">
+              <a:spcAft>
+                <a:spcPts val="1000"/>
+              </a:spcAft>
+              <a:defRPr sz="2200">
+                <a:solidFill>
+                  <a:srgbClr val="464650"/>
+                </a:solidFill>
+                <a:latin typeface="Meiryo"/>
+              </a:defRPr>
+            </a:pPr>
+            <a:r>
+              <a:t>★ エンジニアとしての知見と、親しみやすい発信力が魅力</a:t>
+            </a:r>
+          </a:p>
+          <a:p>
+            <a:pPr algn="l">
+              <a:spcAft>
+                <a:spcPts val="1000"/>
+              </a:spcAft>
+              <a:defRPr sz="2200">
+                <a:solidFill>
+                  <a:srgbClr val="464650"/>
+                </a:solidFill>
+                <a:latin typeface="Meiryo"/>
+              </a:defRPr>
+            </a:pPr>
+            <a:r>
+              <a:t>★ 会場全体が前向きになるトークが大人気</a:t>
+            </a:r>
+          </a:p>
+        </p:txBody>
+      </p:sp>
+    </p:spTree>
+  </p:cSld>
+  <p:clrMapOvr>
+    <a:masterClrMapping/>
+  </p:clrMapOvr>
+</p:sld>
+</file>
+
+<file path=ppt/slides/slide10.xml><?xml version="1.0" encoding="utf-8"?>
+<p:sld xmlns:a="http://schemas.openxmlformats.org/drawingml/2006/main" xmlns:p="http://schemas.openxmlformats.org/presentationml/2006/main" xmlns:r="http://schemas.openxmlformats.org/officeDocument/2006/relationships">
+  <p:cSld>
+    <p:spTree>
+      <p:nvGrpSpPr>
+        <p:cNvPr id="1" name=""/>
+        <p:cNvGrpSpPr/>
+        <p:nvPr/>
+      </p:nvGrpSpPr>
+      <p:grpSpPr/>
+      <p:sp>
+        <p:nvSpPr>
+          <p:cNvPr id="2" name="Rectangle 1"/>
+          <p:cNvSpPr/>
+          <p:nvPr/>
+        </p:nvSpPr>
+        <p:spPr>
+          <a:xfrm>
+            <a:off x="0" y="0"/>
+            <a:ext cx="9144000" cy="6858000"/>
+          </a:xfrm>
+          <a:prstGeom prst="rect">
+            <a:avLst/>
+          </a:prstGeom>
+          <a:solidFill>
+            <a:srgbClr val="FFF6E0"/>
+          </a:solidFill>
+          <a:ln>
+            <a:noFill/>
+          </a:ln>
+        </p:spPr>
+        <p:style>
+          <a:lnRef idx="1">
+            <a:schemeClr val="accent1"/>
+          </a:lnRef>
+          <a:fillRef idx="3">
+            <a:schemeClr val="accent1"/>
+          </a:fillRef>
+          <a:effectRef idx="2">
+            <a:schemeClr val="accent1"/>
+          </a:effectRef>
+          <a:fontRef idx="minor">
+            <a:schemeClr val="lt1"/>
+          </a:fontRef>
+        </p:style>
+        <p:txBody>
+          <a:bodyPr rtlCol="0" anchor="ctr"/>
+          <a:lstStyle/>
+          <a:p>
+            <a:pPr algn="ctr"/>
+          </a:p>
+        </p:txBody>
+      </p:sp>
+      <p:sp>
+        <p:nvSpPr>
+          <p:cNvPr id="3" name="Oval 2"/>
+          <p:cNvSpPr/>
+          <p:nvPr/>
+        </p:nvSpPr>
+        <p:spPr>
+          <a:xfrm>
+            <a:off x="10698480" y="91440"/>
+            <a:ext cx="1280160" cy="1280160"/>
+          </a:xfrm>
+          <a:prstGeom prst="ellipse">
+            <a:avLst/>
+          </a:prstGeom>
+          <a:solidFill>
+            <a:srgbClr val="FFA8C4"/>
+          </a:solidFill>
+          <a:ln>
+            <a:noFill/>
+          </a:ln>
+        </p:spPr>
+        <p:style>
+          <a:lnRef idx="1">
+            <a:schemeClr val="accent1"/>
+          </a:lnRef>
+          <a:fillRef idx="3">
+            <a:schemeClr val="accent1"/>
+          </a:fillRef>
+          <a:effectRef idx="2">
+            <a:schemeClr val="accent1"/>
+          </a:effectRef>
+          <a:fontRef idx="minor">
+            <a:schemeClr val="lt1"/>
+          </a:fontRef>
+        </p:style>
+        <p:txBody>
+          <a:bodyPr rtlCol="0" anchor="ctr"/>
+          <a:lstStyle/>
+          <a:p>
+            <a:pPr algn="ctr"/>
+          </a:p>
+        </p:txBody>
+      </p:sp>
+      <p:sp>
+        <p:nvSpPr>
+          <p:cNvPr id="4" name="Oval 3"/>
+          <p:cNvSpPr/>
+          <p:nvPr/>
+        </p:nvSpPr>
+        <p:spPr>
+          <a:xfrm>
+            <a:off x="91440" y="5486400"/>
+            <a:ext cx="1097280" cy="1097280"/>
+          </a:xfrm>
+          <a:prstGeom prst="ellipse">
+            <a:avLst/>
+          </a:prstGeom>
+          <a:solidFill>
+            <a:srgbClr val="E2F2FF"/>
+          </a:solidFill>
+          <a:ln>
+            <a:noFill/>
+          </a:ln>
+        </p:spPr>
+        <p:style>
+          <a:lnRef idx="1">
+            <a:schemeClr val="accent1"/>
+          </a:lnRef>
+          <a:fillRef idx="3">
+            <a:schemeClr val="accent1"/>
+          </a:fillRef>
+          <a:effectRef idx="2">
+            <a:schemeClr val="accent1"/>
+          </a:effectRef>
+          <a:fontRef idx="minor">
+            <a:schemeClr val="lt1"/>
+          </a:fontRef>
+        </p:style>
+        <p:txBody>
+          <a:bodyPr rtlCol="0" anchor="ctr"/>
+          <a:lstStyle/>
+          <a:p>
+            <a:pPr algn="ctr"/>
+          </a:p>
+        </p:txBody>
+      </p:sp>
+      <p:sp>
+        <p:nvSpPr>
+          <p:cNvPr id="5" name="Oval 4"/>
+          <p:cNvSpPr/>
+          <p:nvPr/>
+        </p:nvSpPr>
+        <p:spPr>
+          <a:xfrm>
+            <a:off x="9875520" y="5943600"/>
+            <a:ext cx="548640" cy="548640"/>
+          </a:xfrm>
+          <a:prstGeom prst="ellipse">
+            <a:avLst/>
+          </a:prstGeom>
+          <a:solidFill>
+            <a:srgbClr val="EFE8FF"/>
+          </a:solidFill>
+          <a:ln>
+            <a:noFill/>
+          </a:ln>
+        </p:spPr>
+        <p:style>
+          <a:lnRef idx="1">
+            <a:schemeClr val="accent1"/>
+          </a:lnRef>
+          <a:fillRef idx="3">
+            <a:schemeClr val="accent1"/>
+          </a:fillRef>
+          <a:effectRef idx="2">
+            <a:schemeClr val="accent1"/>
+          </a:effectRef>
+          <a:fontRef idx="minor">
+            <a:schemeClr val="lt1"/>
+          </a:fontRef>
+        </p:style>
+        <p:txBody>
+          <a:bodyPr rtlCol="0" anchor="ctr"/>
+          <a:lstStyle/>
+          <a:p>
+            <a:pPr algn="ctr"/>
+          </a:p>
+        </p:txBody>
+      </p:sp>
+      <p:sp>
+        <p:nvSpPr>
+          <p:cNvPr id="6" name="TextBox 5"/>
+          <p:cNvSpPr txBox="1"/>
+          <p:nvPr/>
+        </p:nvSpPr>
+        <p:spPr>
+          <a:xfrm>
+            <a:off x="640080" y="365760"/>
+            <a:ext cx="10607040" cy="822960"/>
+          </a:xfrm>
+          <a:prstGeom prst="rect">
+            <a:avLst/>
+          </a:prstGeom>
+          <a:noFill/>
+        </p:spPr>
+        <p:txBody>
+          <a:bodyPr wrap="none">
+            <a:spAutoFit/>
+          </a:bodyPr>
+          <a:lstStyle/>
+          <a:p>
+            <a:pPr>
+              <a:defRPr b="1" sz="3800">
+                <a:solidFill>
+                  <a:srgbClr val="584A7A"/>
+                </a:solidFill>
+                <a:latin typeface="Meiryo"/>
+              </a:defRPr>
+            </a:pPr>
+            <a:r>
+              <a:t>Let's enjoy &amp; keep learning!</a:t>
+            </a:r>
+          </a:p>
+        </p:txBody>
+      </p:sp>
+      <p:sp>
+        <p:nvSpPr>
+          <p:cNvPr id="7" name="Rounded Rectangle 6"/>
+          <p:cNvSpPr/>
+          <p:nvPr/>
+        </p:nvSpPr>
+        <p:spPr>
+          <a:xfrm>
+            <a:off x="731520" y="1234440"/>
+            <a:ext cx="6035040" cy="594360"/>
+          </a:xfrm>
+          <a:prstGeom prst="roundRect">
+            <a:avLst/>
+          </a:prstGeom>
+          <a:solidFill>
+            <a:srgbClr val="FFFFFF"/>
+          </a:solidFill>
+          <a:ln>
+            <a:solidFill>
+              <a:srgbClr val="FFA8C4"/>
+            </a:solidFill>
+          </a:ln>
+        </p:spPr>
+        <p:style>
+          <a:lnRef idx="1">
+            <a:schemeClr val="accent1"/>
+          </a:lnRef>
+          <a:fillRef idx="3">
+            <a:schemeClr val="accent1"/>
+          </a:fillRef>
+          <a:effectRef idx="2">
+            <a:schemeClr val="accent1"/>
+          </a:effectRef>
+          <a:fontRef idx="minor">
+            <a:schemeClr val="lt1"/>
+          </a:fontRef>
+        </p:style>
+        <p:txBody>
+          <a:bodyPr rtlCol="0" anchor="ctr"/>
+          <a:lstStyle/>
+          <a:p>
+            <a:pPr algn="ctr">
+              <a:defRPr sz="2000" b="1">
+                <a:solidFill>
+                  <a:srgbClr val="584A7A"/>
+                </a:solidFill>
+                <a:latin typeface="Meiryo"/>
+              </a:defRPr>
+            </a:pPr>
+            <a:r>
+              <a:t>かわいく・楽しく・自分らしく</a:t>
+            </a:r>
+          </a:p>
+        </p:txBody>
+      </p:sp>
+      <p:sp>
+        <p:nvSpPr>
+          <p:cNvPr id="8" name="Rounded Rectangle 7"/>
+          <p:cNvSpPr/>
+          <p:nvPr/>
+        </p:nvSpPr>
+        <p:spPr>
+          <a:xfrm>
+            <a:off x="731520" y="2011680"/>
+            <a:ext cx="10058400" cy="4023360"/>
+          </a:xfrm>
+          <a:prstGeom prst="roundRect">
+            <a:avLst/>
+          </a:prstGeom>
+          <a:solidFill>
+            <a:srgbClr val="FFFFFF"/>
+          </a:solidFill>
+          <a:ln>
+            <a:solidFill>
+              <a:srgbClr val="E6E6F0"/>
+            </a:solidFill>
+          </a:ln>
+        </p:spPr>
+        <p:style>
+          <a:lnRef idx="1">
+            <a:schemeClr val="accent1"/>
+          </a:lnRef>
+          <a:fillRef idx="3">
+            <a:schemeClr val="accent1"/>
+          </a:fillRef>
+          <a:effectRef idx="2">
+            <a:schemeClr val="accent1"/>
+          </a:effectRef>
+          <a:fontRef idx="minor">
+            <a:schemeClr val="lt1"/>
+          </a:fontRef>
+        </p:style>
+        <p:txBody>
+          <a:bodyPr rtlCol="0" anchor="ctr" wrap="square"/>
+          <a:lstStyle/>
+          <a:p>
+            <a:pPr algn="l">
+              <a:spcAft>
+                <a:spcPts val="1000"/>
+              </a:spcAft>
+              <a:defRPr sz="2400">
+                <a:solidFill>
+                  <a:srgbClr val="464650"/>
+                </a:solidFill>
+                <a:latin typeface="Meiryo"/>
+              </a:defRPr>
+            </a:pPr>
+            <a:r>
+              <a:t>★ 学びは、続けるほど面白くなる。</a:t>
+            </a:r>
+          </a:p>
+          <a:p>
+            <a:pPr algn="l">
+              <a:spcAft>
+                <a:spcPts val="1000"/>
+              </a:spcAft>
+              <a:defRPr sz="2400">
+                <a:solidFill>
+                  <a:srgbClr val="464650"/>
+                </a:solidFill>
+                <a:latin typeface="Meiryo"/>
+              </a:defRPr>
+            </a:pPr>
+            <a:r>
+              <a:t>★ 今日の出会いを、次の一歩につなげよう。</a:t>
             </a:r>
           </a:p>
         </p:txBody>
@@ -3348,7 +3838,7 @@
             <a:avLst/>
           </a:prstGeom>
           <a:solidFill>
-            <a:srgbClr val="F3F0FF"/>
+            <a:srgbClr val="EFE8FF"/>
           </a:solidFill>
           <a:ln>
             <a:noFill/>
@@ -3384,14 +3874,14 @@
         </p:nvSpPr>
         <p:spPr>
           <a:xfrm>
-            <a:off x="10515600" y="182880"/>
-            <a:ext cx="1371600" cy="1371600"/>
+            <a:off x="10698480" y="91440"/>
+            <a:ext cx="1280160" cy="1280160"/>
           </a:xfrm>
           <a:prstGeom prst="ellipse">
             <a:avLst/>
           </a:prstGeom>
           <a:solidFill>
-            <a:srgbClr val="FFD6E6"/>
+            <a:srgbClr val="FFA8C4"/>
           </a:solidFill>
           <a:ln>
             <a:noFill/>
@@ -3427,14 +3917,14 @@
         </p:nvSpPr>
         <p:spPr>
           <a:xfrm>
-            <a:off x="182880" y="5669280"/>
+            <a:off x="91440" y="5486400"/>
             <a:ext cx="1097280" cy="1097280"/>
           </a:xfrm>
           <a:prstGeom prst="ellipse">
             <a:avLst/>
           </a:prstGeom>
           <a:solidFill>
-            <a:srgbClr val="CEEBFF"/>
+            <a:srgbClr val="E2F2FF"/>
           </a:solidFill>
           <a:ln>
             <a:noFill/>
@@ -3464,14 +3954,57 @@
       </p:sp>
       <p:sp>
         <p:nvSpPr>
-          <p:cNvPr id="5" name="TextBox 4"/>
+          <p:cNvPr id="5" name="Oval 4"/>
+          <p:cNvSpPr/>
+          <p:nvPr/>
+        </p:nvSpPr>
+        <p:spPr>
+          <a:xfrm>
+            <a:off x="9875520" y="5943600"/>
+            <a:ext cx="548640" cy="548640"/>
+          </a:xfrm>
+          <a:prstGeom prst="ellipse">
+            <a:avLst/>
+          </a:prstGeom>
+          <a:solidFill>
+            <a:srgbClr val="EFE8FF"/>
+          </a:solidFill>
+          <a:ln>
+            <a:noFill/>
+          </a:ln>
+        </p:spPr>
+        <p:style>
+          <a:lnRef idx="1">
+            <a:schemeClr val="accent1"/>
+          </a:lnRef>
+          <a:fillRef idx="3">
+            <a:schemeClr val="accent1"/>
+          </a:fillRef>
+          <a:effectRef idx="2">
+            <a:schemeClr val="accent1"/>
+          </a:effectRef>
+          <a:fontRef idx="minor">
+            <a:schemeClr val="lt1"/>
+          </a:fontRef>
+        </p:style>
+        <p:txBody>
+          <a:bodyPr rtlCol="0" anchor="ctr"/>
+          <a:lstStyle/>
+          <a:p>
+            <a:pPr algn="ctr"/>
+          </a:p>
+        </p:txBody>
+      </p:sp>
+      <p:sp>
+        <p:nvSpPr>
+          <p:cNvPr id="6" name="TextBox 5"/>
           <p:cNvSpPr txBox="1"/>
           <p:nvPr/>
         </p:nvSpPr>
         <p:spPr>
           <a:xfrm>
-            <a:off x="731520" y="640080"/>
-            <a:ext cx="10241280" cy="1097280"/>
+            <a:off x="640080" y="365760"/>
+            <a:ext cx="10607040" cy="822960"/>
           </a:xfrm>
           <a:prstGeom prst="rect">
             <a:avLst/>
@@ -3484,87 +4017,161 @@
           </a:bodyPr>
           <a:lstStyle/>
           <a:p>
-            <a:pPr algn="l">
-              <a:defRPr sz="4000" b="1">
+            <a:pPr>
+              <a:defRPr b="1" sz="3800">
                 <a:solidFill>
-                  <a:srgbClr val="4D4D66"/>
+                  <a:srgbClr val="584A7A"/>
                 </a:solidFill>
                 <a:latin typeface="Meiryo"/>
               </a:defRPr>
             </a:pPr>
             <a:r>
-              <a:t>千代田まどかさん（ちょまどさん）</a:t>
-            </a:r>
-          </a:p>
-        </p:txBody>
-      </p:sp>
-      <p:sp>
-        <p:nvSpPr>
-          <p:cNvPr id="6" name="TextBox 5"/>
-          <p:cNvSpPr txBox="1"/>
+              <a:t>プロフィール</a:t>
+            </a:r>
+          </a:p>
+        </p:txBody>
+      </p:sp>
+      <p:sp>
+        <p:nvSpPr>
+          <p:cNvPr id="7" name="Rounded Rectangle 6"/>
+          <p:cNvSpPr/>
           <p:nvPr/>
         </p:nvSpPr>
         <p:spPr>
           <a:xfrm>
-            <a:off x="914400" y="1920240"/>
-            <a:ext cx="9875520" cy="4114800"/>
-          </a:xfrm>
-          <a:prstGeom prst="rect">
-            <a:avLst/>
-          </a:prstGeom>
-          <a:noFill/>
-        </p:spPr>
-        <p:txBody>
-          <a:bodyPr wrap="square">
-            <a:spAutoFit/>
-          </a:bodyPr>
-          <a:lstStyle/>
-          <a:p>
-            <a:pPr>
-              <a:spcAft>
-                <a:spcPts val="1200"/>
-              </a:spcAft>
-              <a:defRPr sz="2400">
+            <a:off x="731520" y="1234440"/>
+            <a:ext cx="6035040" cy="594360"/>
+          </a:xfrm>
+          <a:prstGeom prst="roundRect">
+            <a:avLst/>
+          </a:prstGeom>
+          <a:solidFill>
+            <a:srgbClr val="FFFFFF"/>
+          </a:solidFill>
+          <a:ln>
+            <a:solidFill>
+              <a:srgbClr val="FFA8C4"/>
+            </a:solidFill>
+          </a:ln>
+        </p:spPr>
+        <p:style>
+          <a:lnRef idx="1">
+            <a:schemeClr val="accent1"/>
+          </a:lnRef>
+          <a:fillRef idx="3">
+            <a:schemeClr val="accent1"/>
+          </a:fillRef>
+          <a:effectRef idx="2">
+            <a:schemeClr val="accent1"/>
+          </a:effectRef>
+          <a:fontRef idx="minor">
+            <a:schemeClr val="lt1"/>
+          </a:fontRef>
+        </p:style>
+        <p:txBody>
+          <a:bodyPr rtlCol="0" anchor="ctr"/>
+          <a:lstStyle/>
+          <a:p>
+            <a:pPr algn="ctr">
+              <a:defRPr sz="2000" b="1">
                 <a:solidFill>
-                  <a:srgbClr val="404040"/>
+                  <a:srgbClr val="584A7A"/>
                 </a:solidFill>
                 <a:latin typeface="Meiryo"/>
               </a:defRPr>
             </a:pPr>
             <a:r>
-              <a:t>• エンジニア / テックコミュニティで幅広く活動</a:t>
-            </a:r>
-          </a:p>
-          <a:p>
-            <a:pPr>
+              <a:t>千代田まどかさん（ちょまどさん）</a:t>
+            </a:r>
+          </a:p>
+        </p:txBody>
+      </p:sp>
+      <p:sp>
+        <p:nvSpPr>
+          <p:cNvPr id="8" name="Rounded Rectangle 7"/>
+          <p:cNvSpPr/>
+          <p:nvPr/>
+        </p:nvSpPr>
+        <p:spPr>
+          <a:xfrm>
+            <a:off x="731520" y="2011680"/>
+            <a:ext cx="10058400" cy="4023360"/>
+          </a:xfrm>
+          <a:prstGeom prst="roundRect">
+            <a:avLst/>
+          </a:prstGeom>
+          <a:solidFill>
+            <a:srgbClr val="FFFFFF"/>
+          </a:solidFill>
+          <a:ln>
+            <a:solidFill>
+              <a:srgbClr val="E6E6F0"/>
+            </a:solidFill>
+          </a:ln>
+        </p:spPr>
+        <p:style>
+          <a:lnRef idx="1">
+            <a:schemeClr val="accent1"/>
+          </a:lnRef>
+          <a:fillRef idx="3">
+            <a:schemeClr val="accent1"/>
+          </a:fillRef>
+          <a:effectRef idx="2">
+            <a:schemeClr val="accent1"/>
+          </a:effectRef>
+          <a:fontRef idx="minor">
+            <a:schemeClr val="lt1"/>
+          </a:fontRef>
+        </p:style>
+        <p:txBody>
+          <a:bodyPr rtlCol="0" anchor="ctr" wrap="square"/>
+          <a:lstStyle/>
+          <a:p>
+            <a:pPr algn="l">
               <a:spcAft>
-                <a:spcPts val="1200"/>
+                <a:spcPts val="1000"/>
               </a:spcAft>
-              <a:defRPr sz="2400">
+              <a:defRPr sz="2200">
                 <a:solidFill>
-                  <a:srgbClr val="404040"/>
+                  <a:srgbClr val="464650"/>
                 </a:solidFill>
                 <a:latin typeface="Meiryo"/>
               </a:defRPr>
             </a:pPr>
             <a:r>
-              <a:t>• 学びを楽しく伝える発信が魅力</a:t>
-            </a:r>
-          </a:p>
-          <a:p>
-            <a:pPr>
+              <a:t>★ エンジニア / テックコミュニティで幅広く活動</a:t>
+            </a:r>
+          </a:p>
+          <a:p>
+            <a:pPr algn="l">
               <a:spcAft>
-                <a:spcPts val="1200"/>
+                <a:spcPts val="1000"/>
               </a:spcAft>
-              <a:defRPr sz="2400">
+              <a:defRPr sz="2200">
                 <a:solidFill>
-                  <a:srgbClr val="404040"/>
+                  <a:srgbClr val="464650"/>
                 </a:solidFill>
                 <a:latin typeface="Meiryo"/>
               </a:defRPr>
             </a:pPr>
             <a:r>
-              <a:t>• 親しみやすいトークで大人気</a:t>
+              <a:t>★ 難しい話を「わかる・できる」に変える説明が得意</a:t>
+            </a:r>
+          </a:p>
+          <a:p>
+            <a:pPr algn="l">
+              <a:spcAft>
+                <a:spcPts val="1000"/>
+              </a:spcAft>
+              <a:defRPr sz="2200">
+                <a:solidFill>
+                  <a:srgbClr val="464650"/>
+                </a:solidFill>
+                <a:latin typeface="Meiryo"/>
+              </a:defRPr>
+            </a:pPr>
+            <a:r>
+              <a:t>★ 学習者の気持ちに寄り添うやさしい語り口</a:t>
             </a:r>
           </a:p>
         </p:txBody>
@@ -3602,7 +4209,7 @@
             <a:avLst/>
           </a:prstGeom>
           <a:solidFill>
-            <a:srgbClr val="EEFAF4"/>
+            <a:srgbClr val="E2FAF0"/>
           </a:solidFill>
           <a:ln>
             <a:noFill/>
@@ -3638,14 +4245,14 @@
         </p:nvSpPr>
         <p:spPr>
           <a:xfrm>
-            <a:off x="10515600" y="182880"/>
-            <a:ext cx="1371600" cy="1371600"/>
+            <a:off x="10698480" y="91440"/>
+            <a:ext cx="1280160" cy="1280160"/>
           </a:xfrm>
           <a:prstGeom prst="ellipse">
             <a:avLst/>
           </a:prstGeom>
           <a:solidFill>
-            <a:srgbClr val="FFD6E6"/>
+            <a:srgbClr val="FFA8C4"/>
           </a:solidFill>
           <a:ln>
             <a:noFill/>
@@ -3681,14 +4288,14 @@
         </p:nvSpPr>
         <p:spPr>
           <a:xfrm>
-            <a:off x="182880" y="5669280"/>
+            <a:off x="91440" y="5486400"/>
             <a:ext cx="1097280" cy="1097280"/>
           </a:xfrm>
           <a:prstGeom prst="ellipse">
             <a:avLst/>
           </a:prstGeom>
           <a:solidFill>
-            <a:srgbClr val="CEEBFF"/>
+            <a:srgbClr val="E2F2FF"/>
           </a:solidFill>
           <a:ln>
             <a:noFill/>
@@ -3718,14 +4325,57 @@
       </p:sp>
       <p:sp>
         <p:nvSpPr>
-          <p:cNvPr id="5" name="TextBox 4"/>
+          <p:cNvPr id="5" name="Oval 4"/>
+          <p:cNvSpPr/>
+          <p:nvPr/>
+        </p:nvSpPr>
+        <p:spPr>
+          <a:xfrm>
+            <a:off x="9875520" y="5943600"/>
+            <a:ext cx="548640" cy="548640"/>
+          </a:xfrm>
+          <a:prstGeom prst="ellipse">
+            <a:avLst/>
+          </a:prstGeom>
+          <a:solidFill>
+            <a:srgbClr val="EFE8FF"/>
+          </a:solidFill>
+          <a:ln>
+            <a:noFill/>
+          </a:ln>
+        </p:spPr>
+        <p:style>
+          <a:lnRef idx="1">
+            <a:schemeClr val="accent1"/>
+          </a:lnRef>
+          <a:fillRef idx="3">
+            <a:schemeClr val="accent1"/>
+          </a:fillRef>
+          <a:effectRef idx="2">
+            <a:schemeClr val="accent1"/>
+          </a:effectRef>
+          <a:fontRef idx="minor">
+            <a:schemeClr val="lt1"/>
+          </a:fontRef>
+        </p:style>
+        <p:txBody>
+          <a:bodyPr rtlCol="0" anchor="ctr"/>
+          <a:lstStyle/>
+          <a:p>
+            <a:pPr algn="ctr"/>
+          </a:p>
+        </p:txBody>
+      </p:sp>
+      <p:sp>
+        <p:nvSpPr>
+          <p:cNvPr id="6" name="TextBox 5"/>
           <p:cNvSpPr txBox="1"/>
           <p:nvPr/>
         </p:nvSpPr>
         <p:spPr>
           <a:xfrm>
-            <a:off x="731520" y="640080"/>
-            <a:ext cx="10241280" cy="1097280"/>
+            <a:off x="640080" y="365760"/>
+            <a:ext cx="10607040" cy="822960"/>
           </a:xfrm>
           <a:prstGeom prst="rect">
             <a:avLst/>
@@ -3738,87 +4388,161 @@
           </a:bodyPr>
           <a:lstStyle/>
           <a:p>
-            <a:pPr algn="l">
-              <a:defRPr sz="4000" b="1">
+            <a:pPr>
+              <a:defRPr b="1" sz="3800">
                 <a:solidFill>
-                  <a:srgbClr val="4D4D66"/>
+                  <a:srgbClr val="584A7A"/>
                 </a:solidFill>
                 <a:latin typeface="Meiryo"/>
               </a:defRPr>
             </a:pPr>
             <a:r>
-              <a:t>ここがすごい！</a:t>
-            </a:r>
-          </a:p>
-        </p:txBody>
-      </p:sp>
-      <p:sp>
-        <p:nvSpPr>
-          <p:cNvPr id="6" name="TextBox 5"/>
-          <p:cNvSpPr txBox="1"/>
+              <a:t>ちょまどさんの魅力 3選</a:t>
+            </a:r>
+          </a:p>
+        </p:txBody>
+      </p:sp>
+      <p:sp>
+        <p:nvSpPr>
+          <p:cNvPr id="7" name="Rounded Rectangle 6"/>
+          <p:cNvSpPr/>
           <p:nvPr/>
         </p:nvSpPr>
         <p:spPr>
           <a:xfrm>
-            <a:off x="914400" y="1920240"/>
-            <a:ext cx="9875520" cy="4114800"/>
-          </a:xfrm>
-          <a:prstGeom prst="rect">
-            <a:avLst/>
-          </a:prstGeom>
-          <a:noFill/>
-        </p:spPr>
-        <p:txBody>
-          <a:bodyPr wrap="square">
-            <a:spAutoFit/>
-          </a:bodyPr>
-          <a:lstStyle/>
-          <a:p>
-            <a:pPr>
-              <a:spcAft>
-                <a:spcPts val="1200"/>
-              </a:spcAft>
-              <a:defRPr sz="2400">
+            <a:off x="731520" y="1234440"/>
+            <a:ext cx="6035040" cy="594360"/>
+          </a:xfrm>
+          <a:prstGeom prst="roundRect">
+            <a:avLst/>
+          </a:prstGeom>
+          <a:solidFill>
+            <a:srgbClr val="FFFFFF"/>
+          </a:solidFill>
+          <a:ln>
+            <a:solidFill>
+              <a:srgbClr val="FFA8C4"/>
+            </a:solidFill>
+          </a:ln>
+        </p:spPr>
+        <p:style>
+          <a:lnRef idx="1">
+            <a:schemeClr val="accent1"/>
+          </a:lnRef>
+          <a:fillRef idx="3">
+            <a:schemeClr val="accent1"/>
+          </a:fillRef>
+          <a:effectRef idx="2">
+            <a:schemeClr val="accent1"/>
+          </a:effectRef>
+          <a:fontRef idx="minor">
+            <a:schemeClr val="lt1"/>
+          </a:fontRef>
+        </p:style>
+        <p:txBody>
+          <a:bodyPr rtlCol="0" anchor="ctr"/>
+          <a:lstStyle/>
+          <a:p>
+            <a:pPr algn="ctr">
+              <a:defRPr sz="2000" b="1">
                 <a:solidFill>
-                  <a:srgbClr val="404040"/>
+                  <a:srgbClr val="584A7A"/>
                 </a:solidFill>
                 <a:latin typeface="Meiryo"/>
               </a:defRPr>
             </a:pPr>
             <a:r>
-              <a:t>• 難しい技術をわかりやすく説明</a:t>
-            </a:r>
-          </a:p>
-          <a:p>
-            <a:pPr>
+              <a:t>ここがすごい！</a:t>
+            </a:r>
+          </a:p>
+        </p:txBody>
+      </p:sp>
+      <p:sp>
+        <p:nvSpPr>
+          <p:cNvPr id="8" name="Rounded Rectangle 7"/>
+          <p:cNvSpPr/>
+          <p:nvPr/>
+        </p:nvSpPr>
+        <p:spPr>
+          <a:xfrm>
+            <a:off x="731520" y="2011680"/>
+            <a:ext cx="10058400" cy="4023360"/>
+          </a:xfrm>
+          <a:prstGeom prst="roundRect">
+            <a:avLst/>
+          </a:prstGeom>
+          <a:solidFill>
+            <a:srgbClr val="FFFFFF"/>
+          </a:solidFill>
+          <a:ln>
+            <a:solidFill>
+              <a:srgbClr val="E6E6F0"/>
+            </a:solidFill>
+          </a:ln>
+        </p:spPr>
+        <p:style>
+          <a:lnRef idx="1">
+            <a:schemeClr val="accent1"/>
+          </a:lnRef>
+          <a:fillRef idx="3">
+            <a:schemeClr val="accent1"/>
+          </a:fillRef>
+          <a:effectRef idx="2">
+            <a:schemeClr val="accent1"/>
+          </a:effectRef>
+          <a:fontRef idx="minor">
+            <a:schemeClr val="lt1"/>
+          </a:fontRef>
+        </p:style>
+        <p:txBody>
+          <a:bodyPr rtlCol="0" anchor="ctr" wrap="square"/>
+          <a:lstStyle/>
+          <a:p>
+            <a:pPr algn="l">
               <a:spcAft>
-                <a:spcPts val="1200"/>
+                <a:spcPts val="1000"/>
               </a:spcAft>
-              <a:defRPr sz="2400">
+              <a:defRPr sz="2200">
                 <a:solidFill>
-                  <a:srgbClr val="404040"/>
+                  <a:srgbClr val="464650"/>
                 </a:solidFill>
                 <a:latin typeface="Meiryo"/>
               </a:defRPr>
             </a:pPr>
             <a:r>
-              <a:t>• 初心者にもやさしい目線</a:t>
-            </a:r>
-          </a:p>
-          <a:p>
-            <a:pPr>
+              <a:t>★ 1. 技術の本質をシンプルに伝える力</a:t>
+            </a:r>
+          </a:p>
+          <a:p>
+            <a:pPr algn="l">
               <a:spcAft>
-                <a:spcPts val="1200"/>
+                <a:spcPts val="1000"/>
               </a:spcAft>
-              <a:defRPr sz="2400">
+              <a:defRPr sz="2200">
                 <a:solidFill>
-                  <a:srgbClr val="404040"/>
+                  <a:srgbClr val="464650"/>
                 </a:solidFill>
                 <a:latin typeface="Meiryo"/>
               </a:defRPr>
             </a:pPr>
             <a:r>
-              <a:t>• 聞くと『やってみたい！』が増える</a:t>
+              <a:t>★ 2. 初学者にも届く具体例の多さ</a:t>
+            </a:r>
+          </a:p>
+          <a:p>
+            <a:pPr algn="l">
+              <a:spcAft>
+                <a:spcPts val="1000"/>
+              </a:spcAft>
+              <a:defRPr sz="2200">
+                <a:solidFill>
+                  <a:srgbClr val="464650"/>
+                </a:solidFill>
+                <a:latin typeface="Meiryo"/>
+              </a:defRPr>
+            </a:pPr>
+            <a:r>
+              <a:t>★ 3. 「まず一歩」を後押しするポジティブさ</a:t>
             </a:r>
           </a:p>
         </p:txBody>
@@ -3856,7 +4580,7 @@
             <a:avLst/>
           </a:prstGeom>
           <a:solidFill>
-            <a:srgbClr val="FFF8E8"/>
+            <a:srgbClr val="E2F2FF"/>
           </a:solidFill>
           <a:ln>
             <a:noFill/>
@@ -3892,14 +4616,14 @@
         </p:nvSpPr>
         <p:spPr>
           <a:xfrm>
-            <a:off x="10515600" y="182880"/>
-            <a:ext cx="1371600" cy="1371600"/>
+            <a:off x="10698480" y="91440"/>
+            <a:ext cx="1280160" cy="1280160"/>
           </a:xfrm>
           <a:prstGeom prst="ellipse">
             <a:avLst/>
           </a:prstGeom>
           <a:solidFill>
-            <a:srgbClr val="FFD6E6"/>
+            <a:srgbClr val="FFA8C4"/>
           </a:solidFill>
           <a:ln>
             <a:noFill/>
@@ -3935,14 +4659,14 @@
         </p:nvSpPr>
         <p:spPr>
           <a:xfrm>
-            <a:off x="182880" y="5669280"/>
+            <a:off x="91440" y="5486400"/>
             <a:ext cx="1097280" cy="1097280"/>
           </a:xfrm>
           <a:prstGeom prst="ellipse">
             <a:avLst/>
           </a:prstGeom>
           <a:solidFill>
-            <a:srgbClr val="CEEBFF"/>
+            <a:srgbClr val="E2F2FF"/>
           </a:solidFill>
           <a:ln>
             <a:noFill/>
@@ -3972,14 +4696,57 @@
       </p:sp>
       <p:sp>
         <p:nvSpPr>
-          <p:cNvPr id="5" name="TextBox 4"/>
+          <p:cNvPr id="5" name="Oval 4"/>
+          <p:cNvSpPr/>
+          <p:nvPr/>
+        </p:nvSpPr>
+        <p:spPr>
+          <a:xfrm>
+            <a:off x="9875520" y="5943600"/>
+            <a:ext cx="548640" cy="548640"/>
+          </a:xfrm>
+          <a:prstGeom prst="ellipse">
+            <a:avLst/>
+          </a:prstGeom>
+          <a:solidFill>
+            <a:srgbClr val="EFE8FF"/>
+          </a:solidFill>
+          <a:ln>
+            <a:noFill/>
+          </a:ln>
+        </p:spPr>
+        <p:style>
+          <a:lnRef idx="1">
+            <a:schemeClr val="accent1"/>
+          </a:lnRef>
+          <a:fillRef idx="3">
+            <a:schemeClr val="accent1"/>
+          </a:fillRef>
+          <a:effectRef idx="2">
+            <a:schemeClr val="accent1"/>
+          </a:effectRef>
+          <a:fontRef idx="minor">
+            <a:schemeClr val="lt1"/>
+          </a:fontRef>
+        </p:style>
+        <p:txBody>
+          <a:bodyPr rtlCol="0" anchor="ctr"/>
+          <a:lstStyle/>
+          <a:p>
+            <a:pPr algn="ctr"/>
+          </a:p>
+        </p:txBody>
+      </p:sp>
+      <p:sp>
+        <p:nvSpPr>
+          <p:cNvPr id="6" name="TextBox 5"/>
           <p:cNvSpPr txBox="1"/>
           <p:nvPr/>
         </p:nvSpPr>
         <p:spPr>
           <a:xfrm>
-            <a:off x="731520" y="640080"/>
-            <a:ext cx="10241280" cy="1097280"/>
+            <a:off x="640080" y="365760"/>
+            <a:ext cx="10607040" cy="822960"/>
           </a:xfrm>
           <a:prstGeom prst="rect">
             <a:avLst/>
@@ -3992,87 +4759,161 @@
           </a:bodyPr>
           <a:lstStyle/>
           <a:p>
-            <a:pPr algn="l">
-              <a:defRPr sz="4000" b="1">
+            <a:pPr>
+              <a:defRPr b="1" sz="3800">
                 <a:solidFill>
-                  <a:srgbClr val="4D4D66"/>
+                  <a:srgbClr val="584A7A"/>
                 </a:solidFill>
                 <a:latin typeface="Meiryo"/>
               </a:defRPr>
             </a:pPr>
             <a:r>
-              <a:t>いろんな場所で活躍中</a:t>
-            </a:r>
-          </a:p>
-        </p:txBody>
-      </p:sp>
-      <p:sp>
-        <p:nvSpPr>
-          <p:cNvPr id="6" name="TextBox 5"/>
-          <p:cNvSpPr txBox="1"/>
+              <a:t>発信スタイル</a:t>
+            </a:r>
+          </a:p>
+        </p:txBody>
+      </p:sp>
+      <p:sp>
+        <p:nvSpPr>
+          <p:cNvPr id="7" name="Rounded Rectangle 6"/>
+          <p:cNvSpPr/>
           <p:nvPr/>
         </p:nvSpPr>
         <p:spPr>
           <a:xfrm>
-            <a:off x="914400" y="1920240"/>
-            <a:ext cx="9875520" cy="4114800"/>
-          </a:xfrm>
-          <a:prstGeom prst="rect">
-            <a:avLst/>
-          </a:prstGeom>
-          <a:noFill/>
-        </p:spPr>
-        <p:txBody>
-          <a:bodyPr wrap="square">
-            <a:spAutoFit/>
-          </a:bodyPr>
-          <a:lstStyle/>
-          <a:p>
-            <a:pPr>
-              <a:spcAft>
-                <a:spcPts val="1200"/>
-              </a:spcAft>
-              <a:defRPr sz="2400">
+            <a:off x="731520" y="1234440"/>
+            <a:ext cx="6035040" cy="594360"/>
+          </a:xfrm>
+          <a:prstGeom prst="roundRect">
+            <a:avLst/>
+          </a:prstGeom>
+          <a:solidFill>
+            <a:srgbClr val="FFFFFF"/>
+          </a:solidFill>
+          <a:ln>
+            <a:solidFill>
+              <a:srgbClr val="FFA8C4"/>
+            </a:solidFill>
+          </a:ln>
+        </p:spPr>
+        <p:style>
+          <a:lnRef idx="1">
+            <a:schemeClr val="accent1"/>
+          </a:lnRef>
+          <a:fillRef idx="3">
+            <a:schemeClr val="accent1"/>
+          </a:fillRef>
+          <a:effectRef idx="2">
+            <a:schemeClr val="accent1"/>
+          </a:effectRef>
+          <a:fontRef idx="minor">
+            <a:schemeClr val="lt1"/>
+          </a:fontRef>
+        </p:style>
+        <p:txBody>
+          <a:bodyPr rtlCol="0" anchor="ctr"/>
+          <a:lstStyle/>
+          <a:p>
+            <a:pPr algn="ctr">
+              <a:defRPr sz="2000" b="1">
                 <a:solidFill>
-                  <a:srgbClr val="404040"/>
+                  <a:srgbClr val="584A7A"/>
                 </a:solidFill>
                 <a:latin typeface="Meiryo"/>
               </a:defRPr>
             </a:pPr>
             <a:r>
-              <a:t>• イベント登壇</a:t>
-            </a:r>
-          </a:p>
-          <a:p>
-            <a:pPr>
+              <a:t>学びが続く理由</a:t>
+            </a:r>
+          </a:p>
+        </p:txBody>
+      </p:sp>
+      <p:sp>
+        <p:nvSpPr>
+          <p:cNvPr id="8" name="Rounded Rectangle 7"/>
+          <p:cNvSpPr/>
+          <p:nvPr/>
+        </p:nvSpPr>
+        <p:spPr>
+          <a:xfrm>
+            <a:off x="731520" y="2011680"/>
+            <a:ext cx="10058400" cy="4023360"/>
+          </a:xfrm>
+          <a:prstGeom prst="roundRect">
+            <a:avLst/>
+          </a:prstGeom>
+          <a:solidFill>
+            <a:srgbClr val="FFFFFF"/>
+          </a:solidFill>
+          <a:ln>
+            <a:solidFill>
+              <a:srgbClr val="E6E6F0"/>
+            </a:solidFill>
+          </a:ln>
+        </p:spPr>
+        <p:style>
+          <a:lnRef idx="1">
+            <a:schemeClr val="accent1"/>
+          </a:lnRef>
+          <a:fillRef idx="3">
+            <a:schemeClr val="accent1"/>
+          </a:fillRef>
+          <a:effectRef idx="2">
+            <a:schemeClr val="accent1"/>
+          </a:effectRef>
+          <a:fontRef idx="minor">
+            <a:schemeClr val="lt1"/>
+          </a:fontRef>
+        </p:style>
+        <p:txBody>
+          <a:bodyPr rtlCol="0" anchor="ctr" wrap="square"/>
+          <a:lstStyle/>
+          <a:p>
+            <a:pPr algn="l">
               <a:spcAft>
-                <a:spcPts val="1200"/>
+                <a:spcPts val="1000"/>
               </a:spcAft>
-              <a:defRPr sz="2400">
+              <a:defRPr sz="2200">
                 <a:solidFill>
-                  <a:srgbClr val="404040"/>
+                  <a:srgbClr val="464650"/>
                 </a:solidFill>
                 <a:latin typeface="Meiryo"/>
               </a:defRPr>
             </a:pPr>
             <a:r>
-              <a:t>• SNS・動画・記事での発信</a:t>
-            </a:r>
-          </a:p>
-          <a:p>
-            <a:pPr>
+              <a:t>★ 聞いたその日に試せる実践的なヒント</a:t>
+            </a:r>
+          </a:p>
+          <a:p>
+            <a:pPr algn="l">
               <a:spcAft>
-                <a:spcPts val="1200"/>
+                <a:spcPts val="1000"/>
               </a:spcAft>
-              <a:defRPr sz="2400">
+              <a:defRPr sz="2200">
                 <a:solidFill>
-                  <a:srgbClr val="404040"/>
+                  <a:srgbClr val="464650"/>
                 </a:solidFill>
                 <a:latin typeface="Meiryo"/>
               </a:defRPr>
             </a:pPr>
             <a:r>
-              <a:t>• コミュニティを盛り上げる取り組み</a:t>
+              <a:t>★ 専門用語をかみ砕いたわかりやすい言葉選び</a:t>
+            </a:r>
+          </a:p>
+          <a:p>
+            <a:pPr algn="l">
+              <a:spcAft>
+                <a:spcPts val="1000"/>
+              </a:spcAft>
+              <a:defRPr sz="2200">
+                <a:solidFill>
+                  <a:srgbClr val="464650"/>
+                </a:solidFill>
+                <a:latin typeface="Meiryo"/>
+              </a:defRPr>
+            </a:pPr>
+            <a:r>
+              <a:t>★ チャレンジを楽しむ空気を作るコミュニケーション</a:t>
             </a:r>
           </a:p>
         </p:txBody>
@@ -4110,7 +4951,7 @@
             <a:avLst/>
           </a:prstGeom>
           <a:solidFill>
-            <a:srgbClr val="F0FAFF"/>
+            <a:srgbClr val="FFF6E0"/>
           </a:solidFill>
           <a:ln>
             <a:noFill/>
@@ -4146,14 +4987,14 @@
         </p:nvSpPr>
         <p:spPr>
           <a:xfrm>
-            <a:off x="10515600" y="182880"/>
-            <a:ext cx="1371600" cy="1371600"/>
+            <a:off x="10698480" y="91440"/>
+            <a:ext cx="1280160" cy="1280160"/>
           </a:xfrm>
           <a:prstGeom prst="ellipse">
             <a:avLst/>
           </a:prstGeom>
           <a:solidFill>
-            <a:srgbClr val="FFD6E6"/>
+            <a:srgbClr val="FFA8C4"/>
           </a:solidFill>
           <a:ln>
             <a:noFill/>
@@ -4189,14 +5030,14 @@
         </p:nvSpPr>
         <p:spPr>
           <a:xfrm>
-            <a:off x="182880" y="5669280"/>
+            <a:off x="91440" y="5486400"/>
             <a:ext cx="1097280" cy="1097280"/>
           </a:xfrm>
           <a:prstGeom prst="ellipse">
             <a:avLst/>
           </a:prstGeom>
           <a:solidFill>
-            <a:srgbClr val="CEEBFF"/>
+            <a:srgbClr val="E2F2FF"/>
           </a:solidFill>
           <a:ln>
             <a:noFill/>
@@ -4226,14 +5067,57 @@
       </p:sp>
       <p:sp>
         <p:nvSpPr>
-          <p:cNvPr id="5" name="TextBox 4"/>
+          <p:cNvPr id="5" name="Oval 4"/>
+          <p:cNvSpPr/>
+          <p:nvPr/>
+        </p:nvSpPr>
+        <p:spPr>
+          <a:xfrm>
+            <a:off x="9875520" y="5943600"/>
+            <a:ext cx="548640" cy="548640"/>
+          </a:xfrm>
+          <a:prstGeom prst="ellipse">
+            <a:avLst/>
+          </a:prstGeom>
+          <a:solidFill>
+            <a:srgbClr val="EFE8FF"/>
+          </a:solidFill>
+          <a:ln>
+            <a:noFill/>
+          </a:ln>
+        </p:spPr>
+        <p:style>
+          <a:lnRef idx="1">
+            <a:schemeClr val="accent1"/>
+          </a:lnRef>
+          <a:fillRef idx="3">
+            <a:schemeClr val="accent1"/>
+          </a:fillRef>
+          <a:effectRef idx="2">
+            <a:schemeClr val="accent1"/>
+          </a:effectRef>
+          <a:fontRef idx="minor">
+            <a:schemeClr val="lt1"/>
+          </a:fontRef>
+        </p:style>
+        <p:txBody>
+          <a:bodyPr rtlCol="0" anchor="ctr"/>
+          <a:lstStyle/>
+          <a:p>
+            <a:pPr algn="ctr"/>
+          </a:p>
+        </p:txBody>
+      </p:sp>
+      <p:sp>
+        <p:nvSpPr>
+          <p:cNvPr id="6" name="TextBox 5"/>
           <p:cNvSpPr txBox="1"/>
           <p:nvPr/>
         </p:nvSpPr>
         <p:spPr>
           <a:xfrm>
-            <a:off x="731520" y="640080"/>
-            <a:ext cx="10241280" cy="1097280"/>
+            <a:off x="640080" y="365760"/>
+            <a:ext cx="10607040" cy="822960"/>
           </a:xfrm>
           <a:prstGeom prst="rect">
             <a:avLst/>
@@ -4246,87 +5130,161 @@
           </a:bodyPr>
           <a:lstStyle/>
           <a:p>
-            <a:pPr algn="l">
-              <a:defRPr sz="4000" b="1">
+            <a:pPr>
+              <a:defRPr b="1" sz="3800">
                 <a:solidFill>
-                  <a:srgbClr val="4D4D66"/>
+                  <a:srgbClr val="584A7A"/>
                 </a:solidFill>
                 <a:latin typeface="Meiryo"/>
               </a:defRPr>
             </a:pPr>
             <a:r>
-              <a:t>5/30イベント注目ポイント</a:t>
-            </a:r>
-          </a:p>
-        </p:txBody>
-      </p:sp>
-      <p:sp>
-        <p:nvSpPr>
-          <p:cNvPr id="6" name="TextBox 5"/>
-          <p:cNvSpPr txBox="1"/>
+              <a:t>コミュニティへの貢献</a:t>
+            </a:r>
+          </a:p>
+        </p:txBody>
+      </p:sp>
+      <p:sp>
+        <p:nvSpPr>
+          <p:cNvPr id="7" name="Rounded Rectangle 6"/>
+          <p:cNvSpPr/>
           <p:nvPr/>
         </p:nvSpPr>
         <p:spPr>
           <a:xfrm>
-            <a:off x="914400" y="1920240"/>
-            <a:ext cx="9875520" cy="4114800"/>
-          </a:xfrm>
-          <a:prstGeom prst="rect">
-            <a:avLst/>
-          </a:prstGeom>
-          <a:noFill/>
-        </p:spPr>
-        <p:txBody>
-          <a:bodyPr wrap="square">
-            <a:spAutoFit/>
-          </a:bodyPr>
-          <a:lstStyle/>
-          <a:p>
-            <a:pPr>
-              <a:spcAft>
-                <a:spcPts val="1200"/>
-              </a:spcAft>
-              <a:defRPr sz="2400">
+            <a:off x="731520" y="1234440"/>
+            <a:ext cx="6035040" cy="594360"/>
+          </a:xfrm>
+          <a:prstGeom prst="roundRect">
+            <a:avLst/>
+          </a:prstGeom>
+          <a:solidFill>
+            <a:srgbClr val="FFFFFF"/>
+          </a:solidFill>
+          <a:ln>
+            <a:solidFill>
+              <a:srgbClr val="FFA8C4"/>
+            </a:solidFill>
+          </a:ln>
+        </p:spPr>
+        <p:style>
+          <a:lnRef idx="1">
+            <a:schemeClr val="accent1"/>
+          </a:lnRef>
+          <a:fillRef idx="3">
+            <a:schemeClr val="accent1"/>
+          </a:fillRef>
+          <a:effectRef idx="2">
+            <a:schemeClr val="accent1"/>
+          </a:effectRef>
+          <a:fontRef idx="minor">
+            <a:schemeClr val="lt1"/>
+          </a:fontRef>
+        </p:style>
+        <p:txBody>
+          <a:bodyPr rtlCol="0" anchor="ctr"/>
+          <a:lstStyle/>
+          <a:p>
+            <a:pPr algn="ctr">
+              <a:defRPr sz="2000" b="1">
                 <a:solidFill>
-                  <a:srgbClr val="404040"/>
+                  <a:srgbClr val="584A7A"/>
                 </a:solidFill>
                 <a:latin typeface="Meiryo"/>
               </a:defRPr>
             </a:pPr>
             <a:r>
-              <a:t>• どんなテーマの話が聞ける？</a:t>
-            </a:r>
-          </a:p>
-          <a:p>
-            <a:pPr>
+              <a:t>いろんな場所で活躍中</a:t>
+            </a:r>
+          </a:p>
+        </p:txBody>
+      </p:sp>
+      <p:sp>
+        <p:nvSpPr>
+          <p:cNvPr id="8" name="Rounded Rectangle 7"/>
+          <p:cNvSpPr/>
+          <p:nvPr/>
+        </p:nvSpPr>
+        <p:spPr>
+          <a:xfrm>
+            <a:off x="731520" y="2011680"/>
+            <a:ext cx="10058400" cy="4023360"/>
+          </a:xfrm>
+          <a:prstGeom prst="roundRect">
+            <a:avLst/>
+          </a:prstGeom>
+          <a:solidFill>
+            <a:srgbClr val="FFFFFF"/>
+          </a:solidFill>
+          <a:ln>
+            <a:solidFill>
+              <a:srgbClr val="E6E6F0"/>
+            </a:solidFill>
+          </a:ln>
+        </p:spPr>
+        <p:style>
+          <a:lnRef idx="1">
+            <a:schemeClr val="accent1"/>
+          </a:lnRef>
+          <a:fillRef idx="3">
+            <a:schemeClr val="accent1"/>
+          </a:fillRef>
+          <a:effectRef idx="2">
+            <a:schemeClr val="accent1"/>
+          </a:effectRef>
+          <a:fontRef idx="minor">
+            <a:schemeClr val="lt1"/>
+          </a:fontRef>
+        </p:style>
+        <p:txBody>
+          <a:bodyPr rtlCol="0" anchor="ctr" wrap="square"/>
+          <a:lstStyle/>
+          <a:p>
+            <a:pPr algn="l">
               <a:spcAft>
-                <a:spcPts val="1200"/>
+                <a:spcPts val="1000"/>
               </a:spcAft>
-              <a:defRPr sz="2400">
+              <a:defRPr sz="2200">
                 <a:solidFill>
-                  <a:srgbClr val="404040"/>
+                  <a:srgbClr val="464650"/>
                 </a:solidFill>
                 <a:latin typeface="Meiryo"/>
               </a:defRPr>
             </a:pPr>
             <a:r>
-              <a:t>• 明日から使える学び</a:t>
-            </a:r>
-          </a:p>
-          <a:p>
-            <a:pPr>
+              <a:t>★ イベント登壇で学びのきっかけを提供</a:t>
+            </a:r>
+          </a:p>
+          <a:p>
+            <a:pPr algn="l">
               <a:spcAft>
-                <a:spcPts val="1200"/>
+                <a:spcPts val="1000"/>
               </a:spcAft>
-              <a:defRPr sz="2400">
+              <a:defRPr sz="2200">
                 <a:solidFill>
-                  <a:srgbClr val="404040"/>
+                  <a:srgbClr val="464650"/>
                 </a:solidFill>
                 <a:latin typeface="Meiryo"/>
               </a:defRPr>
             </a:pPr>
             <a:r>
-              <a:t>• 参加者みんなで楽しむ空気感</a:t>
+              <a:t>★ SNS・動画・記事で継続的に知見を発信</a:t>
+            </a:r>
+          </a:p>
+          <a:p>
+            <a:pPr algn="l">
+              <a:spcAft>
+                <a:spcPts val="1000"/>
+              </a:spcAft>
+              <a:defRPr sz="2200">
+                <a:solidFill>
+                  <a:srgbClr val="464650"/>
+                </a:solidFill>
+                <a:latin typeface="Meiryo"/>
+              </a:defRPr>
+            </a:pPr>
+            <a:r>
+              <a:t>★ 世代や経験を超えてつながる場づくり</a:t>
             </a:r>
           </a:p>
         </p:txBody>
@@ -4364,7 +5322,7 @@
             <a:avLst/>
           </a:prstGeom>
           <a:solidFill>
-            <a:srgbClr val="FCF2FF"/>
+            <a:srgbClr val="FFE5F0"/>
           </a:solidFill>
           <a:ln>
             <a:noFill/>
@@ -4400,14 +5358,14 @@
         </p:nvSpPr>
         <p:spPr>
           <a:xfrm>
-            <a:off x="10515600" y="182880"/>
-            <a:ext cx="1371600" cy="1371600"/>
+            <a:off x="10698480" y="91440"/>
+            <a:ext cx="1280160" cy="1280160"/>
           </a:xfrm>
           <a:prstGeom prst="ellipse">
             <a:avLst/>
           </a:prstGeom>
           <a:solidFill>
-            <a:srgbClr val="FFD6E6"/>
+            <a:srgbClr val="FFA8C4"/>
           </a:solidFill>
           <a:ln>
             <a:noFill/>
@@ -4443,14 +5401,14 @@
         </p:nvSpPr>
         <p:spPr>
           <a:xfrm>
-            <a:off x="182880" y="5669280"/>
+            <a:off x="91440" y="5486400"/>
             <a:ext cx="1097280" cy="1097280"/>
           </a:xfrm>
           <a:prstGeom prst="ellipse">
             <a:avLst/>
           </a:prstGeom>
           <a:solidFill>
-            <a:srgbClr val="CEEBFF"/>
+            <a:srgbClr val="E2F2FF"/>
           </a:solidFill>
           <a:ln>
             <a:noFill/>
@@ -4480,14 +5438,57 @@
       </p:sp>
       <p:sp>
         <p:nvSpPr>
-          <p:cNvPr id="5" name="TextBox 4"/>
+          <p:cNvPr id="5" name="Oval 4"/>
+          <p:cNvSpPr/>
+          <p:nvPr/>
+        </p:nvSpPr>
+        <p:spPr>
+          <a:xfrm>
+            <a:off x="9875520" y="5943600"/>
+            <a:ext cx="548640" cy="548640"/>
+          </a:xfrm>
+          <a:prstGeom prst="ellipse">
+            <a:avLst/>
+          </a:prstGeom>
+          <a:solidFill>
+            <a:srgbClr val="EFE8FF"/>
+          </a:solidFill>
+          <a:ln>
+            <a:noFill/>
+          </a:ln>
+        </p:spPr>
+        <p:style>
+          <a:lnRef idx="1">
+            <a:schemeClr val="accent1"/>
+          </a:lnRef>
+          <a:fillRef idx="3">
+            <a:schemeClr val="accent1"/>
+          </a:fillRef>
+          <a:effectRef idx="2">
+            <a:schemeClr val="accent1"/>
+          </a:effectRef>
+          <a:fontRef idx="minor">
+            <a:schemeClr val="lt1"/>
+          </a:fontRef>
+        </p:style>
+        <p:txBody>
+          <a:bodyPr rtlCol="0" anchor="ctr"/>
+          <a:lstStyle/>
+          <a:p>
+            <a:pPr algn="ctr"/>
+          </a:p>
+        </p:txBody>
+      </p:sp>
+      <p:sp>
+        <p:nvSpPr>
+          <p:cNvPr id="6" name="TextBox 5"/>
           <p:cNvSpPr txBox="1"/>
           <p:nvPr/>
         </p:nvSpPr>
         <p:spPr>
           <a:xfrm>
-            <a:off x="731520" y="640080"/>
-            <a:ext cx="10241280" cy="1097280"/>
+            <a:off x="640080" y="365760"/>
+            <a:ext cx="10607040" cy="822960"/>
           </a:xfrm>
           <a:prstGeom prst="rect">
             <a:avLst/>
@@ -4500,87 +5501,161 @@
           </a:bodyPr>
           <a:lstStyle/>
           <a:p>
-            <a:pPr algn="l">
-              <a:defRPr sz="4000" b="1">
+            <a:pPr>
+              <a:defRPr b="1" sz="3800">
                 <a:solidFill>
-                  <a:srgbClr val="4D4D66"/>
+                  <a:srgbClr val="584A7A"/>
                 </a:solidFill>
                 <a:latin typeface="Meiryo"/>
               </a:defRPr>
             </a:pPr>
             <a:r>
-              <a:t>こんな気持ちで参加しよう</a:t>
-            </a:r>
-          </a:p>
-        </p:txBody>
-      </p:sp>
-      <p:sp>
-        <p:nvSpPr>
-          <p:cNvPr id="6" name="TextBox 5"/>
-          <p:cNvSpPr txBox="1"/>
+              <a:t>5/30 イベントの注目ポイント</a:t>
+            </a:r>
+          </a:p>
+        </p:txBody>
+      </p:sp>
+      <p:sp>
+        <p:nvSpPr>
+          <p:cNvPr id="7" name="Rounded Rectangle 6"/>
+          <p:cNvSpPr/>
           <p:nvPr/>
         </p:nvSpPr>
         <p:spPr>
           <a:xfrm>
-            <a:off x="914400" y="1920240"/>
-            <a:ext cx="9875520" cy="4114800"/>
-          </a:xfrm>
-          <a:prstGeom prst="rect">
-            <a:avLst/>
-          </a:prstGeom>
-          <a:noFill/>
-        </p:spPr>
-        <p:txBody>
-          <a:bodyPr wrap="square">
-            <a:spAutoFit/>
-          </a:bodyPr>
-          <a:lstStyle/>
-          <a:p>
-            <a:pPr>
-              <a:spcAft>
-                <a:spcPts val="1200"/>
-              </a:spcAft>
-              <a:defRPr sz="2400">
+            <a:off x="731520" y="1234440"/>
+            <a:ext cx="6035040" cy="594360"/>
+          </a:xfrm>
+          <a:prstGeom prst="roundRect">
+            <a:avLst/>
+          </a:prstGeom>
+          <a:solidFill>
+            <a:srgbClr val="FFFFFF"/>
+          </a:solidFill>
+          <a:ln>
+            <a:solidFill>
+              <a:srgbClr val="FFA8C4"/>
+            </a:solidFill>
+          </a:ln>
+        </p:spPr>
+        <p:style>
+          <a:lnRef idx="1">
+            <a:schemeClr val="accent1"/>
+          </a:lnRef>
+          <a:fillRef idx="3">
+            <a:schemeClr val="accent1"/>
+          </a:fillRef>
+          <a:effectRef idx="2">
+            <a:schemeClr val="accent1"/>
+          </a:effectRef>
+          <a:fontRef idx="minor">
+            <a:schemeClr val="lt1"/>
+          </a:fontRef>
+        </p:style>
+        <p:txBody>
+          <a:bodyPr rtlCol="0" anchor="ctr"/>
+          <a:lstStyle/>
+          <a:p>
+            <a:pPr algn="ctr">
+              <a:defRPr sz="2000" b="1">
                 <a:solidFill>
-                  <a:srgbClr val="404040"/>
+                  <a:srgbClr val="584A7A"/>
                 </a:solidFill>
                 <a:latin typeface="Meiryo"/>
               </a:defRPr>
             </a:pPr>
             <a:r>
-              <a:t>• わからないことはそのままでOK</a:t>
-            </a:r>
-          </a:p>
-          <a:p>
-            <a:pPr>
+              <a:t>今日ここを楽しもう！</a:t>
+            </a:r>
+          </a:p>
+        </p:txBody>
+      </p:sp>
+      <p:sp>
+        <p:nvSpPr>
+          <p:cNvPr id="8" name="Rounded Rectangle 7"/>
+          <p:cNvSpPr/>
+          <p:nvPr/>
+        </p:nvSpPr>
+        <p:spPr>
+          <a:xfrm>
+            <a:off x="731520" y="2011680"/>
+            <a:ext cx="10058400" cy="4023360"/>
+          </a:xfrm>
+          <a:prstGeom prst="roundRect">
+            <a:avLst/>
+          </a:prstGeom>
+          <a:solidFill>
+            <a:srgbClr val="FFFFFF"/>
+          </a:solidFill>
+          <a:ln>
+            <a:solidFill>
+              <a:srgbClr val="E6E6F0"/>
+            </a:solidFill>
+          </a:ln>
+        </p:spPr>
+        <p:style>
+          <a:lnRef idx="1">
+            <a:schemeClr val="accent1"/>
+          </a:lnRef>
+          <a:fillRef idx="3">
+            <a:schemeClr val="accent1"/>
+          </a:fillRef>
+          <a:effectRef idx="2">
+            <a:schemeClr val="accent1"/>
+          </a:effectRef>
+          <a:fontRef idx="minor">
+            <a:schemeClr val="lt1"/>
+          </a:fontRef>
+        </p:style>
+        <p:txBody>
+          <a:bodyPr rtlCol="0" anchor="ctr" wrap="square"/>
+          <a:lstStyle/>
+          <a:p>
+            <a:pPr algn="l">
               <a:spcAft>
-                <a:spcPts val="1200"/>
+                <a:spcPts val="1000"/>
               </a:spcAft>
-              <a:defRPr sz="2400">
+              <a:defRPr sz="2200">
                 <a:solidFill>
-                  <a:srgbClr val="404040"/>
+                  <a:srgbClr val="464650"/>
                 </a:solidFill>
                 <a:latin typeface="Meiryo"/>
               </a:defRPr>
             </a:pPr>
             <a:r>
-              <a:t>• 気になったらメモ！</a:t>
-            </a:r>
-          </a:p>
-          <a:p>
-            <a:pPr>
+              <a:t>★ 最新トピックをやさしくキャッチアップ</a:t>
+            </a:r>
+          </a:p>
+          <a:p>
+            <a:pPr algn="l">
               <a:spcAft>
-                <a:spcPts val="1200"/>
+                <a:spcPts val="1000"/>
               </a:spcAft>
-              <a:defRPr sz="2400">
+              <a:defRPr sz="2200">
                 <a:solidFill>
-                  <a:srgbClr val="404040"/>
+                  <a:srgbClr val="464650"/>
                 </a:solidFill>
                 <a:latin typeface="Meiryo"/>
               </a:defRPr>
             </a:pPr>
             <a:r>
-              <a:t>• 一歩だけでも『やってみる』が大事</a:t>
+              <a:t>★ 明日から使えるヒントを持ち帰れる</a:t>
+            </a:r>
+          </a:p>
+          <a:p>
+            <a:pPr algn="l">
+              <a:spcAft>
+                <a:spcPts val="1000"/>
+              </a:spcAft>
+              <a:defRPr sz="2200">
+                <a:solidFill>
+                  <a:srgbClr val="464650"/>
+                </a:solidFill>
+                <a:latin typeface="Meiryo"/>
+              </a:defRPr>
+            </a:pPr>
+            <a:r>
+              <a:t>★ 参加者同士の交流で学びがさらに深まる</a:t>
             </a:r>
           </a:p>
         </p:txBody>
@@ -4618,7 +5693,7 @@
             <a:avLst/>
           </a:prstGeom>
           <a:solidFill>
-            <a:srgbClr val="FFF5ED"/>
+            <a:srgbClr val="EFE8FF"/>
           </a:solidFill>
           <a:ln>
             <a:noFill/>
@@ -4654,14 +5729,14 @@
         </p:nvSpPr>
         <p:spPr>
           <a:xfrm>
-            <a:off x="10515600" y="182880"/>
-            <a:ext cx="1371600" cy="1371600"/>
+            <a:off x="10698480" y="91440"/>
+            <a:ext cx="1280160" cy="1280160"/>
           </a:xfrm>
           <a:prstGeom prst="ellipse">
             <a:avLst/>
           </a:prstGeom>
           <a:solidFill>
-            <a:srgbClr val="FFD6E6"/>
+            <a:srgbClr val="FFA8C4"/>
           </a:solidFill>
           <a:ln>
             <a:noFill/>
@@ -4697,14 +5772,14 @@
         </p:nvSpPr>
         <p:spPr>
           <a:xfrm>
-            <a:off x="182880" y="5669280"/>
+            <a:off x="91440" y="5486400"/>
             <a:ext cx="1097280" cy="1097280"/>
           </a:xfrm>
           <a:prstGeom prst="ellipse">
             <a:avLst/>
           </a:prstGeom>
           <a:solidFill>
-            <a:srgbClr val="CEEBFF"/>
+            <a:srgbClr val="E2F2FF"/>
           </a:solidFill>
           <a:ln>
             <a:noFill/>
@@ -4734,14 +5809,57 @@
       </p:sp>
       <p:sp>
         <p:nvSpPr>
-          <p:cNvPr id="5" name="TextBox 4"/>
+          <p:cNvPr id="5" name="Oval 4"/>
+          <p:cNvSpPr/>
+          <p:nvPr/>
+        </p:nvSpPr>
+        <p:spPr>
+          <a:xfrm>
+            <a:off x="9875520" y="5943600"/>
+            <a:ext cx="548640" cy="548640"/>
+          </a:xfrm>
+          <a:prstGeom prst="ellipse">
+            <a:avLst/>
+          </a:prstGeom>
+          <a:solidFill>
+            <a:srgbClr val="EFE8FF"/>
+          </a:solidFill>
+          <a:ln>
+            <a:noFill/>
+          </a:ln>
+        </p:spPr>
+        <p:style>
+          <a:lnRef idx="1">
+            <a:schemeClr val="accent1"/>
+          </a:lnRef>
+          <a:fillRef idx="3">
+            <a:schemeClr val="accent1"/>
+          </a:fillRef>
+          <a:effectRef idx="2">
+            <a:schemeClr val="accent1"/>
+          </a:effectRef>
+          <a:fontRef idx="minor">
+            <a:schemeClr val="lt1"/>
+          </a:fontRef>
+        </p:style>
+        <p:txBody>
+          <a:bodyPr rtlCol="0" anchor="ctr"/>
+          <a:lstStyle/>
+          <a:p>
+            <a:pPr algn="ctr"/>
+          </a:p>
+        </p:txBody>
+      </p:sp>
+      <p:sp>
+        <p:nvSpPr>
+          <p:cNvPr id="6" name="TextBox 5"/>
           <p:cNvSpPr txBox="1"/>
           <p:nvPr/>
         </p:nvSpPr>
         <p:spPr>
           <a:xfrm>
-            <a:off x="731520" y="640080"/>
-            <a:ext cx="10241280" cy="1097280"/>
+            <a:off x="640080" y="365760"/>
+            <a:ext cx="10607040" cy="822960"/>
           </a:xfrm>
           <a:prstGeom prst="rect">
             <a:avLst/>
@@ -4754,71 +5872,161 @@
           </a:bodyPr>
           <a:lstStyle/>
           <a:p>
-            <a:pPr algn="l">
-              <a:defRPr sz="4000" b="1">
+            <a:pPr>
+              <a:defRPr b="1" sz="3800">
                 <a:solidFill>
-                  <a:srgbClr val="4D4D66"/>
+                  <a:srgbClr val="584A7A"/>
                 </a:solidFill>
                 <a:latin typeface="Meiryo"/>
               </a:defRPr>
             </a:pPr>
             <a:r>
-              <a:t>ちょまどさん、ありがとうございます！</a:t>
-            </a:r>
-          </a:p>
-        </p:txBody>
-      </p:sp>
-      <p:sp>
-        <p:nvSpPr>
-          <p:cNvPr id="6" name="TextBox 5"/>
-          <p:cNvSpPr txBox="1"/>
+              <a:t>こんな人におすすめ</a:t>
+            </a:r>
+          </a:p>
+        </p:txBody>
+      </p:sp>
+      <p:sp>
+        <p:nvSpPr>
+          <p:cNvPr id="7" name="Rounded Rectangle 6"/>
+          <p:cNvSpPr/>
           <p:nvPr/>
         </p:nvSpPr>
         <p:spPr>
           <a:xfrm>
-            <a:off x="914400" y="1920240"/>
-            <a:ext cx="9875520" cy="4114800"/>
-          </a:xfrm>
-          <a:prstGeom prst="rect">
-            <a:avLst/>
-          </a:prstGeom>
-          <a:noFill/>
-        </p:spPr>
-        <p:txBody>
-          <a:bodyPr wrap="square">
-            <a:spAutoFit/>
-          </a:bodyPr>
-          <a:lstStyle/>
-          <a:p>
-            <a:pPr>
-              <a:spcAft>
-                <a:spcPts val="1200"/>
-              </a:spcAft>
-              <a:defRPr sz="2800">
+            <a:off x="731520" y="1234440"/>
+            <a:ext cx="6035040" cy="594360"/>
+          </a:xfrm>
+          <a:prstGeom prst="roundRect">
+            <a:avLst/>
+          </a:prstGeom>
+          <a:solidFill>
+            <a:srgbClr val="FFFFFF"/>
+          </a:solidFill>
+          <a:ln>
+            <a:solidFill>
+              <a:srgbClr val="FFA8C4"/>
+            </a:solidFill>
+          </a:ln>
+        </p:spPr>
+        <p:style>
+          <a:lnRef idx="1">
+            <a:schemeClr val="accent1"/>
+          </a:lnRef>
+          <a:fillRef idx="3">
+            <a:schemeClr val="accent1"/>
+          </a:fillRef>
+          <a:effectRef idx="2">
+            <a:schemeClr val="accent1"/>
+          </a:effectRef>
+          <a:fontRef idx="minor">
+            <a:schemeClr val="lt1"/>
+          </a:fontRef>
+        </p:style>
+        <p:txBody>
+          <a:bodyPr rtlCol="0" anchor="ctr"/>
+          <a:lstStyle/>
+          <a:p>
+            <a:pPr algn="ctr">
+              <a:defRPr sz="2000" b="1">
                 <a:solidFill>
-                  <a:srgbClr val="404040"/>
+                  <a:srgbClr val="584A7A"/>
                 </a:solidFill>
                 <a:latin typeface="Meiryo"/>
               </a:defRPr>
             </a:pPr>
             <a:r>
-              <a:t>• 楽しく学べる時間をありがとうございます</a:t>
-            </a:r>
-          </a:p>
-          <a:p>
-            <a:pPr>
+              <a:t>参加メリット</a:t>
+            </a:r>
+          </a:p>
+        </p:txBody>
+      </p:sp>
+      <p:sp>
+        <p:nvSpPr>
+          <p:cNvPr id="8" name="Rounded Rectangle 7"/>
+          <p:cNvSpPr/>
+          <p:nvPr/>
+        </p:nvSpPr>
+        <p:spPr>
+          <a:xfrm>
+            <a:off x="731520" y="2011680"/>
+            <a:ext cx="10058400" cy="4023360"/>
+          </a:xfrm>
+          <a:prstGeom prst="roundRect">
+            <a:avLst/>
+          </a:prstGeom>
+          <a:solidFill>
+            <a:srgbClr val="FFFFFF"/>
+          </a:solidFill>
+          <a:ln>
+            <a:solidFill>
+              <a:srgbClr val="E6E6F0"/>
+            </a:solidFill>
+          </a:ln>
+        </p:spPr>
+        <p:style>
+          <a:lnRef idx="1">
+            <a:schemeClr val="accent1"/>
+          </a:lnRef>
+          <a:fillRef idx="3">
+            <a:schemeClr val="accent1"/>
+          </a:fillRef>
+          <a:effectRef idx="2">
+            <a:schemeClr val="accent1"/>
+          </a:effectRef>
+          <a:fontRef idx="minor">
+            <a:schemeClr val="lt1"/>
+          </a:fontRef>
+        </p:style>
+        <p:txBody>
+          <a:bodyPr rtlCol="0" anchor="ctr" wrap="square"/>
+          <a:lstStyle/>
+          <a:p>
+            <a:pPr algn="l">
               <a:spcAft>
-                <a:spcPts val="1200"/>
+                <a:spcPts val="1000"/>
               </a:spcAft>
-              <a:defRPr sz="2800">
+              <a:defRPr sz="2200">
                 <a:solidFill>
-                  <a:srgbClr val="404040"/>
+                  <a:srgbClr val="464650"/>
                 </a:solidFill>
                 <a:latin typeface="Meiryo"/>
               </a:defRPr>
             </a:pPr>
             <a:r>
-              <a:t>• 5/30イベント、最高に楽しみましょう！</a:t>
+              <a:t>★ 技術学習のモチベーションを上げたい人</a:t>
+            </a:r>
+          </a:p>
+          <a:p>
+            <a:pPr algn="l">
+              <a:spcAft>
+                <a:spcPts val="1000"/>
+              </a:spcAft>
+              <a:defRPr sz="2200">
+                <a:solidFill>
+                  <a:srgbClr val="464650"/>
+                </a:solidFill>
+                <a:latin typeface="Meiryo"/>
+              </a:defRPr>
+            </a:pPr>
+            <a:r>
+              <a:t>★ やさしく学べるコミュニティに出会いたい人</a:t>
+            </a:r>
+          </a:p>
+          <a:p>
+            <a:pPr algn="l">
+              <a:spcAft>
+                <a:spcPts val="1000"/>
+              </a:spcAft>
+              <a:defRPr sz="2200">
+                <a:solidFill>
+                  <a:srgbClr val="464650"/>
+                </a:solidFill>
+                <a:latin typeface="Meiryo"/>
+              </a:defRPr>
+            </a:pPr>
+            <a:r>
+              <a:t>★ まず一歩を踏み出すきっかけが欲しい人</a:t>
             </a:r>
           </a:p>
         </p:txBody>
@@ -4856,7 +6064,7 @@
             <a:avLst/>
           </a:prstGeom>
           <a:solidFill>
-            <a:srgbClr val="F3FFFA"/>
+            <a:srgbClr val="E2FAF0"/>
           </a:solidFill>
           <a:ln>
             <a:noFill/>
@@ -4892,14 +6100,14 @@
         </p:nvSpPr>
         <p:spPr>
           <a:xfrm>
-            <a:off x="10515600" y="182880"/>
-            <a:ext cx="1371600" cy="1371600"/>
+            <a:off x="10698480" y="91440"/>
+            <a:ext cx="1280160" cy="1280160"/>
           </a:xfrm>
           <a:prstGeom prst="ellipse">
             <a:avLst/>
           </a:prstGeom>
           <a:solidFill>
-            <a:srgbClr val="FFD6E6"/>
+            <a:srgbClr val="FFA8C4"/>
           </a:solidFill>
           <a:ln>
             <a:noFill/>
@@ -4935,14 +6143,14 @@
         </p:nvSpPr>
         <p:spPr>
           <a:xfrm>
-            <a:off x="182880" y="5669280"/>
+            <a:off x="91440" y="5486400"/>
             <a:ext cx="1097280" cy="1097280"/>
           </a:xfrm>
           <a:prstGeom prst="ellipse">
             <a:avLst/>
           </a:prstGeom>
           <a:solidFill>
-            <a:srgbClr val="CEEBFF"/>
+            <a:srgbClr val="E2F2FF"/>
           </a:solidFill>
           <a:ln>
             <a:noFill/>
@@ -4972,14 +6180,57 @@
       </p:sp>
       <p:sp>
         <p:nvSpPr>
-          <p:cNvPr id="5" name="TextBox 4"/>
+          <p:cNvPr id="5" name="Oval 4"/>
+          <p:cNvSpPr/>
+          <p:nvPr/>
+        </p:nvSpPr>
+        <p:spPr>
+          <a:xfrm>
+            <a:off x="9875520" y="5943600"/>
+            <a:ext cx="548640" cy="548640"/>
+          </a:xfrm>
+          <a:prstGeom prst="ellipse">
+            <a:avLst/>
+          </a:prstGeom>
+          <a:solidFill>
+            <a:srgbClr val="EFE8FF"/>
+          </a:solidFill>
+          <a:ln>
+            <a:noFill/>
+          </a:ln>
+        </p:spPr>
+        <p:style>
+          <a:lnRef idx="1">
+            <a:schemeClr val="accent1"/>
+          </a:lnRef>
+          <a:fillRef idx="3">
+            <a:schemeClr val="accent1"/>
+          </a:fillRef>
+          <a:effectRef idx="2">
+            <a:schemeClr val="accent1"/>
+          </a:effectRef>
+          <a:fontRef idx="minor">
+            <a:schemeClr val="lt1"/>
+          </a:fontRef>
+        </p:style>
+        <p:txBody>
+          <a:bodyPr rtlCol="0" anchor="ctr"/>
+          <a:lstStyle/>
+          <a:p>
+            <a:pPr algn="ctr"/>
+          </a:p>
+        </p:txBody>
+      </p:sp>
+      <p:sp>
+        <p:nvSpPr>
+          <p:cNvPr id="6" name="TextBox 5"/>
           <p:cNvSpPr txBox="1"/>
           <p:nvPr/>
         </p:nvSpPr>
         <p:spPr>
           <a:xfrm>
-            <a:off x="731520" y="640080"/>
-            <a:ext cx="10241280" cy="1097280"/>
+            <a:off x="640080" y="365760"/>
+            <a:ext cx="10607040" cy="822960"/>
           </a:xfrm>
           <a:prstGeom prst="rect">
             <a:avLst/>
@@ -4992,55 +6243,516 @@
           </a:bodyPr>
           <a:lstStyle/>
           <a:p>
-            <a:pPr algn="l">
-              <a:defRPr sz="4000" b="1">
+            <a:pPr>
+              <a:defRPr b="1" sz="3800">
                 <a:solidFill>
-                  <a:srgbClr val="4D4D66"/>
+                  <a:srgbClr val="584A7A"/>
                 </a:solidFill>
                 <a:latin typeface="Meiryo"/>
               </a:defRPr>
             </a:pPr>
             <a:r>
-              <a:t>Let’s enjoy &amp; keep learning!</a:t>
-            </a:r>
-          </a:p>
-        </p:txBody>
-      </p:sp>
-      <p:sp>
-        <p:nvSpPr>
-          <p:cNvPr id="6" name="TextBox 5"/>
-          <p:cNvSpPr txBox="1"/>
+              <a:t>参加前のワンポイント</a:t>
+            </a:r>
+          </a:p>
+        </p:txBody>
+      </p:sp>
+      <p:sp>
+        <p:nvSpPr>
+          <p:cNvPr id="7" name="Rounded Rectangle 6"/>
+          <p:cNvSpPr/>
           <p:nvPr/>
         </p:nvSpPr>
         <p:spPr>
           <a:xfrm>
-            <a:off x="914400" y="1920240"/>
-            <a:ext cx="9875520" cy="4114800"/>
-          </a:xfrm>
-          <a:prstGeom prst="rect">
-            <a:avLst/>
-          </a:prstGeom>
-          <a:noFill/>
-        </p:spPr>
-        <p:txBody>
-          <a:bodyPr wrap="square">
-            <a:spAutoFit/>
-          </a:bodyPr>
-          <a:lstStyle/>
-          <a:p>
-            <a:pPr>
-              <a:spcAft>
-                <a:spcPts val="1200"/>
-              </a:spcAft>
-              <a:defRPr sz="2800">
+            <a:off x="731520" y="1234440"/>
+            <a:ext cx="6035040" cy="594360"/>
+          </a:xfrm>
+          <a:prstGeom prst="roundRect">
+            <a:avLst/>
+          </a:prstGeom>
+          <a:solidFill>
+            <a:srgbClr val="FFFFFF"/>
+          </a:solidFill>
+          <a:ln>
+            <a:solidFill>
+              <a:srgbClr val="FFA8C4"/>
+            </a:solidFill>
+          </a:ln>
+        </p:spPr>
+        <p:style>
+          <a:lnRef idx="1">
+            <a:schemeClr val="accent1"/>
+          </a:lnRef>
+          <a:fillRef idx="3">
+            <a:schemeClr val="accent1"/>
+          </a:fillRef>
+          <a:effectRef idx="2">
+            <a:schemeClr val="accent1"/>
+          </a:effectRef>
+          <a:fontRef idx="minor">
+            <a:schemeClr val="lt1"/>
+          </a:fontRef>
+        </p:style>
+        <p:txBody>
+          <a:bodyPr rtlCol="0" anchor="ctr"/>
+          <a:lstStyle/>
+          <a:p>
+            <a:pPr algn="ctr">
+              <a:defRPr sz="2000" b="1">
                 <a:solidFill>
-                  <a:srgbClr val="404040"/>
+                  <a:srgbClr val="584A7A"/>
                 </a:solidFill>
                 <a:latin typeface="Meiryo"/>
               </a:defRPr>
             </a:pPr>
             <a:r>
-              <a:t>• 学びは、かわいく・楽しく・自分らしく。</a:t>
+              <a:t>準備するともっと楽しい</a:t>
+            </a:r>
+          </a:p>
+        </p:txBody>
+      </p:sp>
+      <p:sp>
+        <p:nvSpPr>
+          <p:cNvPr id="8" name="Rounded Rectangle 7"/>
+          <p:cNvSpPr/>
+          <p:nvPr/>
+        </p:nvSpPr>
+        <p:spPr>
+          <a:xfrm>
+            <a:off x="731520" y="2011680"/>
+            <a:ext cx="10058400" cy="4023360"/>
+          </a:xfrm>
+          <a:prstGeom prst="roundRect">
+            <a:avLst/>
+          </a:prstGeom>
+          <a:solidFill>
+            <a:srgbClr val="FFFFFF"/>
+          </a:solidFill>
+          <a:ln>
+            <a:solidFill>
+              <a:srgbClr val="E6E6F0"/>
+            </a:solidFill>
+          </a:ln>
+        </p:spPr>
+        <p:style>
+          <a:lnRef idx="1">
+            <a:schemeClr val="accent1"/>
+          </a:lnRef>
+          <a:fillRef idx="3">
+            <a:schemeClr val="accent1"/>
+          </a:fillRef>
+          <a:effectRef idx="2">
+            <a:schemeClr val="accent1"/>
+          </a:effectRef>
+          <a:fontRef idx="minor">
+            <a:schemeClr val="lt1"/>
+          </a:fontRef>
+        </p:style>
+        <p:txBody>
+          <a:bodyPr rtlCol="0" anchor="ctr" wrap="square"/>
+          <a:lstStyle/>
+          <a:p>
+            <a:pPr algn="l">
+              <a:spcAft>
+                <a:spcPts val="1000"/>
+              </a:spcAft>
+              <a:defRPr sz="2200">
+                <a:solidFill>
+                  <a:srgbClr val="464650"/>
+                </a:solidFill>
+                <a:latin typeface="Meiryo"/>
+              </a:defRPr>
+            </a:pPr>
+            <a:r>
+              <a:t>★ 気になるテーマを1つ決めて聞く</a:t>
+            </a:r>
+          </a:p>
+          <a:p>
+            <a:pPr algn="l">
+              <a:spcAft>
+                <a:spcPts val="1000"/>
+              </a:spcAft>
+              <a:defRPr sz="2200">
+                <a:solidFill>
+                  <a:srgbClr val="464650"/>
+                </a:solidFill>
+                <a:latin typeface="Meiryo"/>
+              </a:defRPr>
+            </a:pPr>
+            <a:r>
+              <a:t>★ 印象に残った言葉をメモする</a:t>
+            </a:r>
+          </a:p>
+          <a:p>
+            <a:pPr algn="l">
+              <a:spcAft>
+                <a:spcPts val="1000"/>
+              </a:spcAft>
+              <a:defRPr sz="2200">
+                <a:solidFill>
+                  <a:srgbClr val="464650"/>
+                </a:solidFill>
+                <a:latin typeface="Meiryo"/>
+              </a:defRPr>
+            </a:pPr>
+            <a:r>
+              <a:t>★ イベント後に1つだけ実践することを決める</a:t>
+            </a:r>
+          </a:p>
+        </p:txBody>
+      </p:sp>
+    </p:spTree>
+  </p:cSld>
+  <p:clrMapOvr>
+    <a:masterClrMapping/>
+  </p:clrMapOvr>
+</p:sld>
+</file>
+
+<file path=ppt/slides/slide9.xml><?xml version="1.0" encoding="utf-8"?>
+<p:sld xmlns:a="http://schemas.openxmlformats.org/drawingml/2006/main" xmlns:p="http://schemas.openxmlformats.org/presentationml/2006/main" xmlns:r="http://schemas.openxmlformats.org/officeDocument/2006/relationships">
+  <p:cSld>
+    <p:spTree>
+      <p:nvGrpSpPr>
+        <p:cNvPr id="1" name=""/>
+        <p:cNvGrpSpPr/>
+        <p:nvPr/>
+      </p:nvGrpSpPr>
+      <p:grpSpPr/>
+      <p:sp>
+        <p:nvSpPr>
+          <p:cNvPr id="2" name="Rectangle 1"/>
+          <p:cNvSpPr/>
+          <p:nvPr/>
+        </p:nvSpPr>
+        <p:spPr>
+          <a:xfrm>
+            <a:off x="0" y="0"/>
+            <a:ext cx="9144000" cy="6858000"/>
+          </a:xfrm>
+          <a:prstGeom prst="rect">
+            <a:avLst/>
+          </a:prstGeom>
+          <a:solidFill>
+            <a:srgbClr val="E2F2FF"/>
+          </a:solidFill>
+          <a:ln>
+            <a:noFill/>
+          </a:ln>
+        </p:spPr>
+        <p:style>
+          <a:lnRef idx="1">
+            <a:schemeClr val="accent1"/>
+          </a:lnRef>
+          <a:fillRef idx="3">
+            <a:schemeClr val="accent1"/>
+          </a:fillRef>
+          <a:effectRef idx="2">
+            <a:schemeClr val="accent1"/>
+          </a:effectRef>
+          <a:fontRef idx="minor">
+            <a:schemeClr val="lt1"/>
+          </a:fontRef>
+        </p:style>
+        <p:txBody>
+          <a:bodyPr rtlCol="0" anchor="ctr"/>
+          <a:lstStyle/>
+          <a:p>
+            <a:pPr algn="ctr"/>
+          </a:p>
+        </p:txBody>
+      </p:sp>
+      <p:sp>
+        <p:nvSpPr>
+          <p:cNvPr id="3" name="Oval 2"/>
+          <p:cNvSpPr/>
+          <p:nvPr/>
+        </p:nvSpPr>
+        <p:spPr>
+          <a:xfrm>
+            <a:off x="10698480" y="91440"/>
+            <a:ext cx="1280160" cy="1280160"/>
+          </a:xfrm>
+          <a:prstGeom prst="ellipse">
+            <a:avLst/>
+          </a:prstGeom>
+          <a:solidFill>
+            <a:srgbClr val="FFA8C4"/>
+          </a:solidFill>
+          <a:ln>
+            <a:noFill/>
+          </a:ln>
+        </p:spPr>
+        <p:style>
+          <a:lnRef idx="1">
+            <a:schemeClr val="accent1"/>
+          </a:lnRef>
+          <a:fillRef idx="3">
+            <a:schemeClr val="accent1"/>
+          </a:fillRef>
+          <a:effectRef idx="2">
+            <a:schemeClr val="accent1"/>
+          </a:effectRef>
+          <a:fontRef idx="minor">
+            <a:schemeClr val="lt1"/>
+          </a:fontRef>
+        </p:style>
+        <p:txBody>
+          <a:bodyPr rtlCol="0" anchor="ctr"/>
+          <a:lstStyle/>
+          <a:p>
+            <a:pPr algn="ctr"/>
+          </a:p>
+        </p:txBody>
+      </p:sp>
+      <p:sp>
+        <p:nvSpPr>
+          <p:cNvPr id="4" name="Oval 3"/>
+          <p:cNvSpPr/>
+          <p:nvPr/>
+        </p:nvSpPr>
+        <p:spPr>
+          <a:xfrm>
+            <a:off x="91440" y="5486400"/>
+            <a:ext cx="1097280" cy="1097280"/>
+          </a:xfrm>
+          <a:prstGeom prst="ellipse">
+            <a:avLst/>
+          </a:prstGeom>
+          <a:solidFill>
+            <a:srgbClr val="E2F2FF"/>
+          </a:solidFill>
+          <a:ln>
+            <a:noFill/>
+          </a:ln>
+        </p:spPr>
+        <p:style>
+          <a:lnRef idx="1">
+            <a:schemeClr val="accent1"/>
+          </a:lnRef>
+          <a:fillRef idx="3">
+            <a:schemeClr val="accent1"/>
+          </a:fillRef>
+          <a:effectRef idx="2">
+            <a:schemeClr val="accent1"/>
+          </a:effectRef>
+          <a:fontRef idx="minor">
+            <a:schemeClr val="lt1"/>
+          </a:fontRef>
+        </p:style>
+        <p:txBody>
+          <a:bodyPr rtlCol="0" anchor="ctr"/>
+          <a:lstStyle/>
+          <a:p>
+            <a:pPr algn="ctr"/>
+          </a:p>
+        </p:txBody>
+      </p:sp>
+      <p:sp>
+        <p:nvSpPr>
+          <p:cNvPr id="5" name="Oval 4"/>
+          <p:cNvSpPr/>
+          <p:nvPr/>
+        </p:nvSpPr>
+        <p:spPr>
+          <a:xfrm>
+            <a:off x="9875520" y="5943600"/>
+            <a:ext cx="548640" cy="548640"/>
+          </a:xfrm>
+          <a:prstGeom prst="ellipse">
+            <a:avLst/>
+          </a:prstGeom>
+          <a:solidFill>
+            <a:srgbClr val="EFE8FF"/>
+          </a:solidFill>
+          <a:ln>
+            <a:noFill/>
+          </a:ln>
+        </p:spPr>
+        <p:style>
+          <a:lnRef idx="1">
+            <a:schemeClr val="accent1"/>
+          </a:lnRef>
+          <a:fillRef idx="3">
+            <a:schemeClr val="accent1"/>
+          </a:fillRef>
+          <a:effectRef idx="2">
+            <a:schemeClr val="accent1"/>
+          </a:effectRef>
+          <a:fontRef idx="minor">
+            <a:schemeClr val="lt1"/>
+          </a:fontRef>
+        </p:style>
+        <p:txBody>
+          <a:bodyPr rtlCol="0" anchor="ctr"/>
+          <a:lstStyle/>
+          <a:p>
+            <a:pPr algn="ctr"/>
+          </a:p>
+        </p:txBody>
+      </p:sp>
+      <p:sp>
+        <p:nvSpPr>
+          <p:cNvPr id="6" name="TextBox 5"/>
+          <p:cNvSpPr txBox="1"/>
+          <p:nvPr/>
+        </p:nvSpPr>
+        <p:spPr>
+          <a:xfrm>
+            <a:off x="640080" y="365760"/>
+            <a:ext cx="10607040" cy="822960"/>
+          </a:xfrm>
+          <a:prstGeom prst="rect">
+            <a:avLst/>
+          </a:prstGeom>
+          <a:noFill/>
+        </p:spPr>
+        <p:txBody>
+          <a:bodyPr wrap="none">
+            <a:spAutoFit/>
+          </a:bodyPr>
+          <a:lstStyle/>
+          <a:p>
+            <a:pPr>
+              <a:defRPr b="1" sz="3800">
+                <a:solidFill>
+                  <a:srgbClr val="584A7A"/>
+                </a:solidFill>
+                <a:latin typeface="Meiryo"/>
+              </a:defRPr>
+            </a:pPr>
+            <a:r>
+              <a:t>ありがとうメッセージ</a:t>
+            </a:r>
+          </a:p>
+        </p:txBody>
+      </p:sp>
+      <p:sp>
+        <p:nvSpPr>
+          <p:cNvPr id="7" name="Rounded Rectangle 6"/>
+          <p:cNvSpPr/>
+          <p:nvPr/>
+        </p:nvSpPr>
+        <p:spPr>
+          <a:xfrm>
+            <a:off x="731520" y="1234440"/>
+            <a:ext cx="6035040" cy="594360"/>
+          </a:xfrm>
+          <a:prstGeom prst="roundRect">
+            <a:avLst/>
+          </a:prstGeom>
+          <a:solidFill>
+            <a:srgbClr val="FFFFFF"/>
+          </a:solidFill>
+          <a:ln>
+            <a:solidFill>
+              <a:srgbClr val="FFA8C4"/>
+            </a:solidFill>
+          </a:ln>
+        </p:spPr>
+        <p:style>
+          <a:lnRef idx="1">
+            <a:schemeClr val="accent1"/>
+          </a:lnRef>
+          <a:fillRef idx="3">
+            <a:schemeClr val="accent1"/>
+          </a:fillRef>
+          <a:effectRef idx="2">
+            <a:schemeClr val="accent1"/>
+          </a:effectRef>
+          <a:fontRef idx="minor">
+            <a:schemeClr val="lt1"/>
+          </a:fontRef>
+        </p:style>
+        <p:txBody>
+          <a:bodyPr rtlCol="0" anchor="ctr"/>
+          <a:lstStyle/>
+          <a:p>
+            <a:pPr algn="ctr">
+              <a:defRPr sz="2000" b="1">
+                <a:solidFill>
+                  <a:srgbClr val="584A7A"/>
+                </a:solidFill>
+                <a:latin typeface="Meiryo"/>
+              </a:defRPr>
+            </a:pPr>
+            <a:r>
+              <a:t>ちょまどさん、ありがとうございます！</a:t>
+            </a:r>
+          </a:p>
+        </p:txBody>
+      </p:sp>
+      <p:sp>
+        <p:nvSpPr>
+          <p:cNvPr id="8" name="Rounded Rectangle 7"/>
+          <p:cNvSpPr/>
+          <p:nvPr/>
+        </p:nvSpPr>
+        <p:spPr>
+          <a:xfrm>
+            <a:off x="731520" y="2011680"/>
+            <a:ext cx="10058400" cy="4023360"/>
+          </a:xfrm>
+          <a:prstGeom prst="roundRect">
+            <a:avLst/>
+          </a:prstGeom>
+          <a:solidFill>
+            <a:srgbClr val="FFFFFF"/>
+          </a:solidFill>
+          <a:ln>
+            <a:solidFill>
+              <a:srgbClr val="E6E6F0"/>
+            </a:solidFill>
+          </a:ln>
+        </p:spPr>
+        <p:style>
+          <a:lnRef idx="1">
+            <a:schemeClr val="accent1"/>
+          </a:lnRef>
+          <a:fillRef idx="3">
+            <a:schemeClr val="accent1"/>
+          </a:fillRef>
+          <a:effectRef idx="2">
+            <a:schemeClr val="accent1"/>
+          </a:effectRef>
+          <a:fontRef idx="minor">
+            <a:schemeClr val="lt1"/>
+          </a:fontRef>
+        </p:style>
+        <p:txBody>
+          <a:bodyPr rtlCol="0" anchor="ctr" wrap="square"/>
+          <a:lstStyle/>
+          <a:p>
+            <a:pPr algn="l">
+              <a:spcAft>
+                <a:spcPts val="1000"/>
+              </a:spcAft>
+              <a:defRPr sz="2400">
+                <a:solidFill>
+                  <a:srgbClr val="464650"/>
+                </a:solidFill>
+                <a:latin typeface="Meiryo"/>
+              </a:defRPr>
+            </a:pPr>
+            <a:r>
+              <a:t>★ 楽しく学べる時間をありがとうございます</a:t>
+            </a:r>
+          </a:p>
+          <a:p>
+            <a:pPr algn="l">
+              <a:spcAft>
+                <a:spcPts val="1000"/>
+              </a:spcAft>
+              <a:defRPr sz="2400">
+                <a:solidFill>
+                  <a:srgbClr val="464650"/>
+                </a:solidFill>
+                <a:latin typeface="Meiryo"/>
+              </a:defRPr>
+            </a:pPr>
+            <a:r>
+              <a:t>★ 5/30イベント、みんなで最高の1日にしましょう！</a:t>
             </a:r>
           </a:p>
         </p:txBody>

</xml_diff>